<commit_message>
changes to file for customization
</commit_message>
<xml_diff>
--- a/CMS-AI-Translation-Strategy.pptx
+++ b/CMS-AI-Translation-Strategy.pptx
@@ -121,21 +121,116 @@
 </p:presentation>
 </file>
 
+<file path=ppt/revisionInfo.xml><?xml version="1.0" encoding="utf-8"?>
+<p1510:revInfo xmlns:a="http://schemas.openxmlformats.org/drawingml/2006/main" xmlns:r="http://schemas.openxmlformats.org/officeDocument/2006/relationships" xmlns:p1510="http://schemas.microsoft.com/office/powerpoint/2015/10/main">
+  <p1510:revLst>
+    <p1510:client id="{812AAA5F-06D1-4E05-BF24-B11565BC0FBC}" v="10" dt="2026-03-06T05:02:26.156"/>
+  </p1510:revLst>
+</p1510:revInfo>
+</file>
+
 <file path=ppt/changesInfos/changesInfo1.xml><?xml version="1.0" encoding="utf-8"?>
 <pc:chgInfo xmlns:a="http://schemas.openxmlformats.org/drawingml/2006/main" xmlns:r="http://schemas.openxmlformats.org/officeDocument/2006/relationships" xmlns:ac="http://schemas.microsoft.com/office/drawing/2013/main/command" xmlns:pc="http://schemas.microsoft.com/office/powerpoint/2013/main/command">
   <pc:docChgLst>
     <pc:chgData name="Raghavendra Angara" userId="6b971708-5412-4b70-9031-36da4ebff12f" providerId="ADAL" clId="{FF26F244-2771-4A64-A430-D1400A5380B4}"/>
-    <pc:docChg chg="mod modSld">
-      <pc:chgData name="Raghavendra Angara" userId="6b971708-5412-4b70-9031-36da4ebff12f" providerId="ADAL" clId="{FF26F244-2771-4A64-A430-D1400A5380B4}" dt="2026-03-05T19:03:41.199" v="16" actId="1036"/>
+    <pc:docChg chg="undo custSel mod addSld delSld modSld">
+      <pc:chgData name="Raghavendra Angara" userId="6b971708-5412-4b70-9031-36da4ebff12f" providerId="ADAL" clId="{FF26F244-2771-4A64-A430-D1400A5380B4}" dt="2026-03-06T05:14:14.645" v="233" actId="6549"/>
       <pc:docMkLst>
         <pc:docMk/>
       </pc:docMkLst>
-      <pc:sldChg chg="modSp mod">
-        <pc:chgData name="Raghavendra Angara" userId="6b971708-5412-4b70-9031-36da4ebff12f" providerId="ADAL" clId="{FF26F244-2771-4A64-A430-D1400A5380B4}" dt="2026-03-05T19:03:41.199" v="16" actId="1036"/>
+      <pc:sldChg chg="modSp mod setBg">
+        <pc:chgData name="Raghavendra Angara" userId="6b971708-5412-4b70-9031-36da4ebff12f" providerId="ADAL" clId="{FF26F244-2771-4A64-A430-D1400A5380B4}" dt="2026-03-06T05:02:59.673" v="87" actId="2711"/>
+        <pc:sldMkLst>
+          <pc:docMk/>
+          <pc:sldMk cId="0" sldId="256"/>
+        </pc:sldMkLst>
+        <pc:spChg chg="mod">
+          <ac:chgData name="Raghavendra Angara" userId="6b971708-5412-4b70-9031-36da4ebff12f" providerId="ADAL" clId="{FF26F244-2771-4A64-A430-D1400A5380B4}" dt="2026-03-06T05:02:38.078" v="86" actId="6549"/>
+          <ac:spMkLst>
+            <pc:docMk/>
+            <pc:sldMk cId="0" sldId="256"/>
+            <ac:spMk id="4" creationId="{00000000-0000-0000-0000-000000000000}"/>
+          </ac:spMkLst>
+        </pc:spChg>
+        <pc:spChg chg="mod">
+          <ac:chgData name="Raghavendra Angara" userId="6b971708-5412-4b70-9031-36da4ebff12f" providerId="ADAL" clId="{FF26F244-2771-4A64-A430-D1400A5380B4}" dt="2026-03-06T05:00:58.168" v="52" actId="1076"/>
+          <ac:spMkLst>
+            <pc:docMk/>
+            <pc:sldMk cId="0" sldId="256"/>
+            <ac:spMk id="5" creationId="{00000000-0000-0000-0000-000000000000}"/>
+          </ac:spMkLst>
+        </pc:spChg>
+        <pc:spChg chg="mod">
+          <ac:chgData name="Raghavendra Angara" userId="6b971708-5412-4b70-9031-36da4ebff12f" providerId="ADAL" clId="{FF26F244-2771-4A64-A430-D1400A5380B4}" dt="2026-03-06T05:01:02.199" v="53" actId="1076"/>
+          <ac:spMkLst>
+            <pc:docMk/>
+            <pc:sldMk cId="0" sldId="256"/>
+            <ac:spMk id="6" creationId="{00000000-0000-0000-0000-000000000000}"/>
+          </ac:spMkLst>
+        </pc:spChg>
+        <pc:spChg chg="mod">
+          <ac:chgData name="Raghavendra Angara" userId="6b971708-5412-4b70-9031-36da4ebff12f" providerId="ADAL" clId="{FF26F244-2771-4A64-A430-D1400A5380B4}" dt="2026-03-06T05:02:59.673" v="87" actId="2711"/>
+          <ac:spMkLst>
+            <pc:docMk/>
+            <pc:sldMk cId="0" sldId="256"/>
+            <ac:spMk id="7" creationId="{00000000-0000-0000-0000-000000000000}"/>
+          </ac:spMkLst>
+        </pc:spChg>
+        <pc:spChg chg="mod">
+          <ac:chgData name="Raghavendra Angara" userId="6b971708-5412-4b70-9031-36da4ebff12f" providerId="ADAL" clId="{FF26F244-2771-4A64-A430-D1400A5380B4}" dt="2026-03-06T02:19:37.711" v="30" actId="207"/>
+          <ac:spMkLst>
+            <pc:docMk/>
+            <pc:sldMk cId="0" sldId="256"/>
+            <ac:spMk id="8" creationId="{00000000-0000-0000-0000-000000000000}"/>
+          </ac:spMkLst>
+        </pc:spChg>
+        <pc:spChg chg="mod">
+          <ac:chgData name="Raghavendra Angara" userId="6b971708-5412-4b70-9031-36da4ebff12f" providerId="ADAL" clId="{FF26F244-2771-4A64-A430-D1400A5380B4}" dt="2026-03-06T02:19:37.711" v="30" actId="207"/>
+          <ac:spMkLst>
+            <pc:docMk/>
+            <pc:sldMk cId="0" sldId="256"/>
+            <ac:spMk id="12" creationId="{00000000-0000-0000-0000-000000000000}"/>
+          </ac:spMkLst>
+        </pc:spChg>
+        <pc:spChg chg="mod">
+          <ac:chgData name="Raghavendra Angara" userId="6b971708-5412-4b70-9031-36da4ebff12f" providerId="ADAL" clId="{FF26F244-2771-4A64-A430-D1400A5380B4}" dt="2026-03-06T02:19:37.711" v="30" actId="207"/>
+          <ac:spMkLst>
+            <pc:docMk/>
+            <pc:sldMk cId="0" sldId="256"/>
+            <ac:spMk id="16" creationId="{00000000-0000-0000-0000-000000000000}"/>
+          </ac:spMkLst>
+        </pc:spChg>
+        <pc:spChg chg="mod">
+          <ac:chgData name="Raghavendra Angara" userId="6b971708-5412-4b70-9031-36da4ebff12f" providerId="ADAL" clId="{FF26F244-2771-4A64-A430-D1400A5380B4}" dt="2026-03-06T02:19:37.711" v="30" actId="207"/>
+          <ac:spMkLst>
+            <pc:docMk/>
+            <pc:sldMk cId="0" sldId="256"/>
+            <ac:spMk id="20" creationId="{00000000-0000-0000-0000-000000000000}"/>
+          </ac:spMkLst>
+        </pc:spChg>
+        <pc:spChg chg="mod">
+          <ac:chgData name="Raghavendra Angara" userId="6b971708-5412-4b70-9031-36da4ebff12f" providerId="ADAL" clId="{FF26F244-2771-4A64-A430-D1400A5380B4}" dt="2026-03-06T05:02:32.073" v="85"/>
+          <ac:spMkLst>
+            <pc:docMk/>
+            <pc:sldMk cId="0" sldId="256"/>
+            <ac:spMk id="24" creationId="{00000000-0000-0000-0000-000000000000}"/>
+          </ac:spMkLst>
+        </pc:spChg>
+      </pc:sldChg>
+      <pc:sldChg chg="modSp mod setBg">
+        <pc:chgData name="Raghavendra Angara" userId="6b971708-5412-4b70-9031-36da4ebff12f" providerId="ADAL" clId="{FF26F244-2771-4A64-A430-D1400A5380B4}" dt="2026-03-06T05:04:32.345" v="150" actId="1036"/>
         <pc:sldMkLst>
           <pc:docMk/>
           <pc:sldMk cId="0" sldId="257"/>
         </pc:sldMkLst>
+        <pc:spChg chg="mod">
+          <ac:chgData name="Raghavendra Angara" userId="6b971708-5412-4b70-9031-36da4ebff12f" providerId="ADAL" clId="{FF26F244-2771-4A64-A430-D1400A5380B4}" dt="2026-03-06T02:19:39.434" v="33" actId="207"/>
+          <ac:spMkLst>
+            <pc:docMk/>
+            <pc:sldMk cId="0" sldId="257"/>
+            <ac:spMk id="11" creationId="{00000000-0000-0000-0000-000000000000}"/>
+          </ac:spMkLst>
+        </pc:spChg>
         <pc:spChg chg="mod">
           <ac:chgData name="Raghavendra Angara" userId="6b971708-5412-4b70-9031-36da4ebff12f" providerId="ADAL" clId="{FF26F244-2771-4A64-A430-D1400A5380B4}" dt="2026-03-05T19:03:30.319" v="5" actId="1036"/>
           <ac:spMkLst>
@@ -153,11 +248,773 @@
           </ac:spMkLst>
         </pc:spChg>
         <pc:spChg chg="mod">
+          <ac:chgData name="Raghavendra Angara" userId="6b971708-5412-4b70-9031-36da4ebff12f" providerId="ADAL" clId="{FF26F244-2771-4A64-A430-D1400A5380B4}" dt="2026-03-06T05:04:32.345" v="150" actId="1036"/>
+          <ac:spMkLst>
+            <pc:docMk/>
+            <pc:sldMk cId="0" sldId="257"/>
+            <ac:spMk id="23" creationId="{00000000-0000-0000-0000-000000000000}"/>
+          </ac:spMkLst>
+        </pc:spChg>
+        <pc:spChg chg="mod">
           <ac:chgData name="Raghavendra Angara" userId="6b971708-5412-4b70-9031-36da4ebff12f" providerId="ADAL" clId="{FF26F244-2771-4A64-A430-D1400A5380B4}" dt="2026-03-05T19:03:41.199" v="16" actId="1036"/>
           <ac:spMkLst>
             <pc:docMk/>
             <pc:sldMk cId="0" sldId="257"/>
             <ac:spMk id="24" creationId="{00000000-0000-0000-0000-000000000000}"/>
+          </ac:spMkLst>
+        </pc:spChg>
+        <pc:spChg chg="mod">
+          <ac:chgData name="Raghavendra Angara" userId="6b971708-5412-4b70-9031-36da4ebff12f" providerId="ADAL" clId="{FF26F244-2771-4A64-A430-D1400A5380B4}" dt="2026-03-06T02:19:38.979" v="32" actId="207"/>
+          <ac:spMkLst>
+            <pc:docMk/>
+            <pc:sldMk cId="0" sldId="257"/>
+            <ac:spMk id="29" creationId="{00000000-0000-0000-0000-000000000000}"/>
+          </ac:spMkLst>
+        </pc:spChg>
+        <pc:spChg chg="mod">
+          <ac:chgData name="Raghavendra Angara" userId="6b971708-5412-4b70-9031-36da4ebff12f" providerId="ADAL" clId="{FF26F244-2771-4A64-A430-D1400A5380B4}" dt="2026-03-06T05:03:24.431" v="99" actId="1036"/>
+          <ac:spMkLst>
+            <pc:docMk/>
+            <pc:sldMk cId="0" sldId="257"/>
+            <ac:spMk id="34" creationId="{00000000-0000-0000-0000-000000000000}"/>
+          </ac:spMkLst>
+        </pc:spChg>
+        <pc:spChg chg="mod">
+          <ac:chgData name="Raghavendra Angara" userId="6b971708-5412-4b70-9031-36da4ebff12f" providerId="ADAL" clId="{FF26F244-2771-4A64-A430-D1400A5380B4}" dt="2026-03-06T05:03:21.752" v="96" actId="1036"/>
+          <ac:spMkLst>
+            <pc:docMk/>
+            <pc:sldMk cId="0" sldId="257"/>
+            <ac:spMk id="35" creationId="{00000000-0000-0000-0000-000000000000}"/>
+          </ac:spMkLst>
+        </pc:spChg>
+        <pc:spChg chg="mod">
+          <ac:chgData name="Raghavendra Angara" userId="6b971708-5412-4b70-9031-36da4ebff12f" providerId="ADAL" clId="{FF26F244-2771-4A64-A430-D1400A5380B4}" dt="2026-03-06T05:03:18.854" v="93" actId="1036"/>
+          <ac:spMkLst>
+            <pc:docMk/>
+            <pc:sldMk cId="0" sldId="257"/>
+            <ac:spMk id="37" creationId="{00000000-0000-0000-0000-000000000000}"/>
+          </ac:spMkLst>
+        </pc:spChg>
+        <pc:spChg chg="mod">
+          <ac:chgData name="Raghavendra Angara" userId="6b971708-5412-4b70-9031-36da4ebff12f" providerId="ADAL" clId="{FF26F244-2771-4A64-A430-D1400A5380B4}" dt="2026-03-06T05:03:15.015" v="90" actId="1036"/>
+          <ac:spMkLst>
+            <pc:docMk/>
+            <pc:sldMk cId="0" sldId="257"/>
+            <ac:spMk id="38" creationId="{00000000-0000-0000-0000-000000000000}"/>
+          </ac:spMkLst>
+        </pc:spChg>
+        <pc:spChg chg="mod">
+          <ac:chgData name="Raghavendra Angara" userId="6b971708-5412-4b70-9031-36da4ebff12f" providerId="ADAL" clId="{FF26F244-2771-4A64-A430-D1400A5380B4}" dt="2026-03-06T05:04:25.626" v="148" actId="1036"/>
+          <ac:spMkLst>
+            <pc:docMk/>
+            <pc:sldMk cId="0" sldId="257"/>
+            <ac:spMk id="42" creationId="{00000000-0000-0000-0000-000000000000}"/>
+          </ac:spMkLst>
+        </pc:spChg>
+        <pc:spChg chg="mod">
+          <ac:chgData name="Raghavendra Angara" userId="6b971708-5412-4b70-9031-36da4ebff12f" providerId="ADAL" clId="{FF26F244-2771-4A64-A430-D1400A5380B4}" dt="2026-03-06T05:03:39.391" v="109" actId="1036"/>
+          <ac:spMkLst>
+            <pc:docMk/>
+            <pc:sldMk cId="0" sldId="257"/>
+            <ac:spMk id="52" creationId="{00000000-0000-0000-0000-000000000000}"/>
+          </ac:spMkLst>
+        </pc:spChg>
+        <pc:spChg chg="mod">
+          <ac:chgData name="Raghavendra Angara" userId="6b971708-5412-4b70-9031-36da4ebff12f" providerId="ADAL" clId="{FF26F244-2771-4A64-A430-D1400A5380B4}" dt="2026-03-06T05:03:34.367" v="103" actId="1036"/>
+          <ac:spMkLst>
+            <pc:docMk/>
+            <pc:sldMk cId="0" sldId="257"/>
+            <ac:spMk id="53" creationId="{00000000-0000-0000-0000-000000000000}"/>
+          </ac:spMkLst>
+        </pc:spChg>
+        <pc:spChg chg="mod">
+          <ac:chgData name="Raghavendra Angara" userId="6b971708-5412-4b70-9031-36da4ebff12f" providerId="ADAL" clId="{FF26F244-2771-4A64-A430-D1400A5380B4}" dt="2026-03-06T05:03:41.675" v="112" actId="1036"/>
+          <ac:spMkLst>
+            <pc:docMk/>
+            <pc:sldMk cId="0" sldId="257"/>
+            <ac:spMk id="55" creationId="{00000000-0000-0000-0000-000000000000}"/>
+          </ac:spMkLst>
+        </pc:spChg>
+        <pc:spChg chg="mod">
+          <ac:chgData name="Raghavendra Angara" userId="6b971708-5412-4b70-9031-36da4ebff12f" providerId="ADAL" clId="{FF26F244-2771-4A64-A430-D1400A5380B4}" dt="2026-03-06T05:03:35.940" v="106" actId="1036"/>
+          <ac:spMkLst>
+            <pc:docMk/>
+            <pc:sldMk cId="0" sldId="257"/>
+            <ac:spMk id="56" creationId="{00000000-0000-0000-0000-000000000000}"/>
+          </ac:spMkLst>
+        </pc:spChg>
+        <pc:spChg chg="mod">
+          <ac:chgData name="Raghavendra Angara" userId="6b971708-5412-4b70-9031-36da4ebff12f" providerId="ADAL" clId="{FF26F244-2771-4A64-A430-D1400A5380B4}" dt="2026-03-06T05:04:23.505" v="146" actId="1036"/>
+          <ac:spMkLst>
+            <pc:docMk/>
+            <pc:sldMk cId="0" sldId="257"/>
+            <ac:spMk id="59" creationId="{00000000-0000-0000-0000-000000000000}"/>
+          </ac:spMkLst>
+        </pc:spChg>
+        <pc:spChg chg="mod">
+          <ac:chgData name="Raghavendra Angara" userId="6b971708-5412-4b70-9031-36da4ebff12f" providerId="ADAL" clId="{FF26F244-2771-4A64-A430-D1400A5380B4}" dt="2026-03-06T05:04:22.327" v="144" actId="1036"/>
+          <ac:spMkLst>
+            <pc:docMk/>
+            <pc:sldMk cId="0" sldId="257"/>
+            <ac:spMk id="60" creationId="{00000000-0000-0000-0000-000000000000}"/>
+          </ac:spMkLst>
+        </pc:spChg>
+        <pc:spChg chg="mod">
+          <ac:chgData name="Raghavendra Angara" userId="6b971708-5412-4b70-9031-36da4ebff12f" providerId="ADAL" clId="{FF26F244-2771-4A64-A430-D1400A5380B4}" dt="2026-03-06T05:03:57.528" v="124" actId="1036"/>
+          <ac:spMkLst>
+            <pc:docMk/>
+            <pc:sldMk cId="0" sldId="257"/>
+            <ac:spMk id="70" creationId="{00000000-0000-0000-0000-000000000000}"/>
+          </ac:spMkLst>
+        </pc:spChg>
+        <pc:spChg chg="mod">
+          <ac:chgData name="Raghavendra Angara" userId="6b971708-5412-4b70-9031-36da4ebff12f" providerId="ADAL" clId="{FF26F244-2771-4A64-A430-D1400A5380B4}" dt="2026-03-06T05:03:52.097" v="116" actId="1036"/>
+          <ac:spMkLst>
+            <pc:docMk/>
+            <pc:sldMk cId="0" sldId="257"/>
+            <ac:spMk id="71" creationId="{00000000-0000-0000-0000-000000000000}"/>
+          </ac:spMkLst>
+        </pc:spChg>
+        <pc:spChg chg="mod">
+          <ac:chgData name="Raghavendra Angara" userId="6b971708-5412-4b70-9031-36da4ebff12f" providerId="ADAL" clId="{FF26F244-2771-4A64-A430-D1400A5380B4}" dt="2026-03-06T05:03:55.560" v="120" actId="1036"/>
+          <ac:spMkLst>
+            <pc:docMk/>
+            <pc:sldMk cId="0" sldId="257"/>
+            <ac:spMk id="73" creationId="{00000000-0000-0000-0000-000000000000}"/>
+          </ac:spMkLst>
+        </pc:spChg>
+        <pc:spChg chg="mod">
+          <ac:chgData name="Raghavendra Angara" userId="6b971708-5412-4b70-9031-36da4ebff12f" providerId="ADAL" clId="{FF26F244-2771-4A64-A430-D1400A5380B4}" dt="2026-03-06T05:03:52.097" v="116" actId="1036"/>
+          <ac:spMkLst>
+            <pc:docMk/>
+            <pc:sldMk cId="0" sldId="257"/>
+            <ac:spMk id="74" creationId="{00000000-0000-0000-0000-000000000000}"/>
+          </ac:spMkLst>
+        </pc:spChg>
+        <pc:spChg chg="mod">
+          <ac:chgData name="Raghavendra Angara" userId="6b971708-5412-4b70-9031-36da4ebff12f" providerId="ADAL" clId="{FF26F244-2771-4A64-A430-D1400A5380B4}" dt="2026-03-06T05:04:20.798" v="142" actId="1036"/>
+          <ac:spMkLst>
+            <pc:docMk/>
+            <pc:sldMk cId="0" sldId="257"/>
+            <ac:spMk id="77" creationId="{00000000-0000-0000-0000-000000000000}"/>
+          </ac:spMkLst>
+        </pc:spChg>
+        <pc:spChg chg="mod">
+          <ac:chgData name="Raghavendra Angara" userId="6b971708-5412-4b70-9031-36da4ebff12f" providerId="ADAL" clId="{FF26F244-2771-4A64-A430-D1400A5380B4}" dt="2026-03-06T05:04:18.175" v="140" actId="1036"/>
+          <ac:spMkLst>
+            <pc:docMk/>
+            <pc:sldMk cId="0" sldId="257"/>
+            <ac:spMk id="78" creationId="{00000000-0000-0000-0000-000000000000}"/>
+          </ac:spMkLst>
+        </pc:spChg>
+        <pc:spChg chg="mod">
+          <ac:chgData name="Raghavendra Angara" userId="6b971708-5412-4b70-9031-36da4ebff12f" providerId="ADAL" clId="{FF26F244-2771-4A64-A430-D1400A5380B4}" dt="2026-03-06T05:04:09.219" v="130" actId="1036"/>
+          <ac:spMkLst>
+            <pc:docMk/>
+            <pc:sldMk cId="0" sldId="257"/>
+            <ac:spMk id="86" creationId="{00000000-0000-0000-0000-000000000000}"/>
+          </ac:spMkLst>
+        </pc:spChg>
+        <pc:spChg chg="mod">
+          <ac:chgData name="Raghavendra Angara" userId="6b971708-5412-4b70-9031-36da4ebff12f" providerId="ADAL" clId="{FF26F244-2771-4A64-A430-D1400A5380B4}" dt="2026-03-06T05:04:01.950" v="126" actId="1035"/>
+          <ac:spMkLst>
+            <pc:docMk/>
+            <pc:sldMk cId="0" sldId="257"/>
+            <ac:spMk id="87" creationId="{00000000-0000-0000-0000-000000000000}"/>
+          </ac:spMkLst>
+        </pc:spChg>
+        <pc:spChg chg="mod">
+          <ac:chgData name="Raghavendra Angara" userId="6b971708-5412-4b70-9031-36da4ebff12f" providerId="ADAL" clId="{FF26F244-2771-4A64-A430-D1400A5380B4}" dt="2026-03-06T05:04:11.716" v="134" actId="1036"/>
+          <ac:spMkLst>
+            <pc:docMk/>
+            <pc:sldMk cId="0" sldId="257"/>
+            <ac:spMk id="89" creationId="{00000000-0000-0000-0000-000000000000}"/>
+          </ac:spMkLst>
+        </pc:spChg>
+        <pc:spChg chg="mod">
+          <ac:chgData name="Raghavendra Angara" userId="6b971708-5412-4b70-9031-36da4ebff12f" providerId="ADAL" clId="{FF26F244-2771-4A64-A430-D1400A5380B4}" dt="2026-03-06T05:03:52.097" v="116" actId="1036"/>
+          <ac:spMkLst>
+            <pc:docMk/>
+            <pc:sldMk cId="0" sldId="257"/>
+            <ac:spMk id="90" creationId="{00000000-0000-0000-0000-000000000000}"/>
+          </ac:spMkLst>
+        </pc:spChg>
+        <pc:spChg chg="mod">
+          <ac:chgData name="Raghavendra Angara" userId="6b971708-5412-4b70-9031-36da4ebff12f" providerId="ADAL" clId="{FF26F244-2771-4A64-A430-D1400A5380B4}" dt="2026-03-06T05:04:16.174" v="138" actId="1036"/>
+          <ac:spMkLst>
+            <pc:docMk/>
+            <pc:sldMk cId="0" sldId="257"/>
+            <ac:spMk id="93" creationId="{00000000-0000-0000-0000-000000000000}"/>
+          </ac:spMkLst>
+        </pc:spChg>
+        <pc:spChg chg="mod">
+          <ac:chgData name="Raghavendra Angara" userId="6b971708-5412-4b70-9031-36da4ebff12f" providerId="ADAL" clId="{FF26F244-2771-4A64-A430-D1400A5380B4}" dt="2026-03-06T05:04:14.914" v="136" actId="1036"/>
+          <ac:spMkLst>
+            <pc:docMk/>
+            <pc:sldMk cId="0" sldId="257"/>
+            <ac:spMk id="94" creationId="{00000000-0000-0000-0000-000000000000}"/>
+          </ac:spMkLst>
+        </pc:spChg>
+      </pc:sldChg>
+      <pc:sldChg chg="modSp mod">
+        <pc:chgData name="Raghavendra Angara" userId="6b971708-5412-4b70-9031-36da4ebff12f" providerId="ADAL" clId="{FF26F244-2771-4A64-A430-D1400A5380B4}" dt="2026-03-06T05:05:29.363" v="176" actId="20577"/>
+        <pc:sldMkLst>
+          <pc:docMk/>
+          <pc:sldMk cId="0" sldId="258"/>
+        </pc:sldMkLst>
+        <pc:spChg chg="mod">
+          <ac:chgData name="Raghavendra Angara" userId="6b971708-5412-4b70-9031-36da4ebff12f" providerId="ADAL" clId="{FF26F244-2771-4A64-A430-D1400A5380B4}" dt="2026-03-06T05:04:49.590" v="151" actId="2711"/>
+          <ac:spMkLst>
+            <pc:docMk/>
+            <pc:sldMk cId="0" sldId="258"/>
+            <ac:spMk id="5" creationId="{00000000-0000-0000-0000-000000000000}"/>
+          </ac:spMkLst>
+        </pc:spChg>
+        <pc:spChg chg="mod">
+          <ac:chgData name="Raghavendra Angara" userId="6b971708-5412-4b70-9031-36da4ebff12f" providerId="ADAL" clId="{FF26F244-2771-4A64-A430-D1400A5380B4}" dt="2026-03-06T05:05:29.363" v="176" actId="20577"/>
+          <ac:spMkLst>
+            <pc:docMk/>
+            <pc:sldMk cId="0" sldId="258"/>
+            <ac:spMk id="11" creationId="{00000000-0000-0000-0000-000000000000}"/>
+          </ac:spMkLst>
+        </pc:spChg>
+      </pc:sldChg>
+      <pc:sldChg chg="modSp mod">
+        <pc:chgData name="Raghavendra Angara" userId="6b971708-5412-4b70-9031-36da4ebff12f" providerId="ADAL" clId="{FF26F244-2771-4A64-A430-D1400A5380B4}" dt="2026-03-06T05:14:14.645" v="233" actId="6549"/>
+        <pc:sldMkLst>
+          <pc:docMk/>
+          <pc:sldMk cId="0" sldId="259"/>
+        </pc:sldMkLst>
+        <pc:spChg chg="mod">
+          <ac:chgData name="Raghavendra Angara" userId="6b971708-5412-4b70-9031-36da4ebff12f" providerId="ADAL" clId="{FF26F244-2771-4A64-A430-D1400A5380B4}" dt="2026-03-06T05:14:14.645" v="233" actId="6549"/>
+          <ac:spMkLst>
+            <pc:docMk/>
+            <pc:sldMk cId="0" sldId="259"/>
+            <ac:spMk id="3" creationId="{00000000-0000-0000-0000-000000000000}"/>
+          </ac:spMkLst>
+        </pc:spChg>
+      </pc:sldChg>
+      <pc:sldChg chg="delSp modSp mod">
+        <pc:chgData name="Raghavendra Angara" userId="6b971708-5412-4b70-9031-36da4ebff12f" providerId="ADAL" clId="{FF26F244-2771-4A64-A430-D1400A5380B4}" dt="2026-03-06T05:10:30.377" v="218" actId="14100"/>
+        <pc:sldMkLst>
+          <pc:docMk/>
+          <pc:sldMk cId="0" sldId="260"/>
+        </pc:sldMkLst>
+        <pc:spChg chg="del">
+          <ac:chgData name="Raghavendra Angara" userId="6b971708-5412-4b70-9031-36da4ebff12f" providerId="ADAL" clId="{FF26F244-2771-4A64-A430-D1400A5380B4}" dt="2026-03-06T05:10:05.778" v="211" actId="478"/>
+          <ac:spMkLst>
+            <pc:docMk/>
+            <pc:sldMk cId="0" sldId="260"/>
+            <ac:spMk id="9" creationId="{00000000-0000-0000-0000-000000000000}"/>
+          </ac:spMkLst>
+        </pc:spChg>
+        <pc:spChg chg="mod">
+          <ac:chgData name="Raghavendra Angara" userId="6b971708-5412-4b70-9031-36da4ebff12f" providerId="ADAL" clId="{FF26F244-2771-4A64-A430-D1400A5380B4}" dt="2026-03-06T05:07:14.992" v="180" actId="1076"/>
+          <ac:spMkLst>
+            <pc:docMk/>
+            <pc:sldMk cId="0" sldId="260"/>
+            <ac:spMk id="10" creationId="{00000000-0000-0000-0000-000000000000}"/>
+          </ac:spMkLst>
+        </pc:spChg>
+        <pc:spChg chg="mod">
+          <ac:chgData name="Raghavendra Angara" userId="6b971708-5412-4b70-9031-36da4ebff12f" providerId="ADAL" clId="{FF26F244-2771-4A64-A430-D1400A5380B4}" dt="2026-03-06T05:07:14.992" v="180" actId="1076"/>
+          <ac:spMkLst>
+            <pc:docMk/>
+            <pc:sldMk cId="0" sldId="260"/>
+            <ac:spMk id="11" creationId="{00000000-0000-0000-0000-000000000000}"/>
+          </ac:spMkLst>
+        </pc:spChg>
+        <pc:spChg chg="mod">
+          <ac:chgData name="Raghavendra Angara" userId="6b971708-5412-4b70-9031-36da4ebff12f" providerId="ADAL" clId="{FF26F244-2771-4A64-A430-D1400A5380B4}" dt="2026-03-06T05:07:14.992" v="180" actId="1076"/>
+          <ac:spMkLst>
+            <pc:docMk/>
+            <pc:sldMk cId="0" sldId="260"/>
+            <ac:spMk id="12" creationId="{00000000-0000-0000-0000-000000000000}"/>
+          </ac:spMkLst>
+        </pc:spChg>
+        <pc:spChg chg="mod">
+          <ac:chgData name="Raghavendra Angara" userId="6b971708-5412-4b70-9031-36da4ebff12f" providerId="ADAL" clId="{FF26F244-2771-4A64-A430-D1400A5380B4}" dt="2026-03-06T05:07:14.992" v="180" actId="1076"/>
+          <ac:spMkLst>
+            <pc:docMk/>
+            <pc:sldMk cId="0" sldId="260"/>
+            <ac:spMk id="13" creationId="{00000000-0000-0000-0000-000000000000}"/>
+          </ac:spMkLst>
+        </pc:spChg>
+        <pc:spChg chg="mod">
+          <ac:chgData name="Raghavendra Angara" userId="6b971708-5412-4b70-9031-36da4ebff12f" providerId="ADAL" clId="{FF26F244-2771-4A64-A430-D1400A5380B4}" dt="2026-03-06T05:07:14.992" v="180" actId="1076"/>
+          <ac:spMkLst>
+            <pc:docMk/>
+            <pc:sldMk cId="0" sldId="260"/>
+            <ac:spMk id="14" creationId="{00000000-0000-0000-0000-000000000000}"/>
+          </ac:spMkLst>
+        </pc:spChg>
+        <pc:spChg chg="del">
+          <ac:chgData name="Raghavendra Angara" userId="6b971708-5412-4b70-9031-36da4ebff12f" providerId="ADAL" clId="{FF26F244-2771-4A64-A430-D1400A5380B4}" dt="2026-03-06T05:07:28.149" v="181" actId="478"/>
+          <ac:spMkLst>
+            <pc:docMk/>
+            <pc:sldMk cId="0" sldId="260"/>
+            <ac:spMk id="15" creationId="{00000000-0000-0000-0000-000000000000}"/>
+          </ac:spMkLst>
+        </pc:spChg>
+        <pc:spChg chg="del">
+          <ac:chgData name="Raghavendra Angara" userId="6b971708-5412-4b70-9031-36da4ebff12f" providerId="ADAL" clId="{FF26F244-2771-4A64-A430-D1400A5380B4}" dt="2026-03-06T05:07:28.149" v="181" actId="478"/>
+          <ac:spMkLst>
+            <pc:docMk/>
+            <pc:sldMk cId="0" sldId="260"/>
+            <ac:spMk id="16" creationId="{00000000-0000-0000-0000-000000000000}"/>
+          </ac:spMkLst>
+        </pc:spChg>
+        <pc:spChg chg="del">
+          <ac:chgData name="Raghavendra Angara" userId="6b971708-5412-4b70-9031-36da4ebff12f" providerId="ADAL" clId="{FF26F244-2771-4A64-A430-D1400A5380B4}" dt="2026-03-06T05:07:28.149" v="181" actId="478"/>
+          <ac:spMkLst>
+            <pc:docMk/>
+            <pc:sldMk cId="0" sldId="260"/>
+            <ac:spMk id="17" creationId="{00000000-0000-0000-0000-000000000000}"/>
+          </ac:spMkLst>
+        </pc:spChg>
+        <pc:spChg chg="del">
+          <ac:chgData name="Raghavendra Angara" userId="6b971708-5412-4b70-9031-36da4ebff12f" providerId="ADAL" clId="{FF26F244-2771-4A64-A430-D1400A5380B4}" dt="2026-03-06T05:07:28.149" v="181" actId="478"/>
+          <ac:spMkLst>
+            <pc:docMk/>
+            <pc:sldMk cId="0" sldId="260"/>
+            <ac:spMk id="18" creationId="{00000000-0000-0000-0000-000000000000}"/>
+          </ac:spMkLst>
+        </pc:spChg>
+        <pc:spChg chg="del">
+          <ac:chgData name="Raghavendra Angara" userId="6b971708-5412-4b70-9031-36da4ebff12f" providerId="ADAL" clId="{FF26F244-2771-4A64-A430-D1400A5380B4}" dt="2026-03-06T05:07:28.149" v="181" actId="478"/>
+          <ac:spMkLst>
+            <pc:docMk/>
+            <pc:sldMk cId="0" sldId="260"/>
+            <ac:spMk id="19" creationId="{00000000-0000-0000-0000-000000000000}"/>
+          </ac:spMkLst>
+        </pc:spChg>
+        <pc:spChg chg="del">
+          <ac:chgData name="Raghavendra Angara" userId="6b971708-5412-4b70-9031-36da4ebff12f" providerId="ADAL" clId="{FF26F244-2771-4A64-A430-D1400A5380B4}" dt="2026-03-06T05:07:28.149" v="181" actId="478"/>
+          <ac:spMkLst>
+            <pc:docMk/>
+            <pc:sldMk cId="0" sldId="260"/>
+            <ac:spMk id="20" creationId="{00000000-0000-0000-0000-000000000000}"/>
+          </ac:spMkLst>
+        </pc:spChg>
+        <pc:spChg chg="del mod">
+          <ac:chgData name="Raghavendra Angara" userId="6b971708-5412-4b70-9031-36da4ebff12f" providerId="ADAL" clId="{FF26F244-2771-4A64-A430-D1400A5380B4}" dt="2026-03-06T05:10:08.855" v="212" actId="478"/>
+          <ac:spMkLst>
+            <pc:docMk/>
+            <pc:sldMk cId="0" sldId="260"/>
+            <ac:spMk id="21" creationId="{00000000-0000-0000-0000-000000000000}"/>
+          </ac:spMkLst>
+        </pc:spChg>
+        <pc:spChg chg="mod">
+          <ac:chgData name="Raghavendra Angara" userId="6b971708-5412-4b70-9031-36da4ebff12f" providerId="ADAL" clId="{FF26F244-2771-4A64-A430-D1400A5380B4}" dt="2026-03-06T05:08:05.188" v="185" actId="1076"/>
+          <ac:spMkLst>
+            <pc:docMk/>
+            <pc:sldMk cId="0" sldId="260"/>
+            <ac:spMk id="22" creationId="{00000000-0000-0000-0000-000000000000}"/>
+          </ac:spMkLst>
+        </pc:spChg>
+        <pc:spChg chg="mod">
+          <ac:chgData name="Raghavendra Angara" userId="6b971708-5412-4b70-9031-36da4ebff12f" providerId="ADAL" clId="{FF26F244-2771-4A64-A430-D1400A5380B4}" dt="2026-03-06T05:08:05.188" v="185" actId="1076"/>
+          <ac:spMkLst>
+            <pc:docMk/>
+            <pc:sldMk cId="0" sldId="260"/>
+            <ac:spMk id="23" creationId="{00000000-0000-0000-0000-000000000000}"/>
+          </ac:spMkLst>
+        </pc:spChg>
+        <pc:spChg chg="mod">
+          <ac:chgData name="Raghavendra Angara" userId="6b971708-5412-4b70-9031-36da4ebff12f" providerId="ADAL" clId="{FF26F244-2771-4A64-A430-D1400A5380B4}" dt="2026-03-06T05:08:26.816" v="188" actId="20577"/>
+          <ac:spMkLst>
+            <pc:docMk/>
+            <pc:sldMk cId="0" sldId="260"/>
+            <ac:spMk id="24" creationId="{00000000-0000-0000-0000-000000000000}"/>
+          </ac:spMkLst>
+        </pc:spChg>
+        <pc:spChg chg="mod">
+          <ac:chgData name="Raghavendra Angara" userId="6b971708-5412-4b70-9031-36da4ebff12f" providerId="ADAL" clId="{FF26F244-2771-4A64-A430-D1400A5380B4}" dt="2026-03-06T05:08:05.188" v="185" actId="1076"/>
+          <ac:spMkLst>
+            <pc:docMk/>
+            <pc:sldMk cId="0" sldId="260"/>
+            <ac:spMk id="25" creationId="{00000000-0000-0000-0000-000000000000}"/>
+          </ac:spMkLst>
+        </pc:spChg>
+        <pc:spChg chg="mod">
+          <ac:chgData name="Raghavendra Angara" userId="6b971708-5412-4b70-9031-36da4ebff12f" providerId="ADAL" clId="{FF26F244-2771-4A64-A430-D1400A5380B4}" dt="2026-03-06T05:08:05.188" v="185" actId="1076"/>
+          <ac:spMkLst>
+            <pc:docMk/>
+            <pc:sldMk cId="0" sldId="260"/>
+            <ac:spMk id="26" creationId="{00000000-0000-0000-0000-000000000000}"/>
+          </ac:spMkLst>
+        </pc:spChg>
+        <pc:spChg chg="mod">
+          <ac:chgData name="Raghavendra Angara" userId="6b971708-5412-4b70-9031-36da4ebff12f" providerId="ADAL" clId="{FF26F244-2771-4A64-A430-D1400A5380B4}" dt="2026-03-06T05:08:52.805" v="198" actId="14100"/>
+          <ac:spMkLst>
+            <pc:docMk/>
+            <pc:sldMk cId="0" sldId="260"/>
+            <ac:spMk id="27" creationId="{00000000-0000-0000-0000-000000000000}"/>
+          </ac:spMkLst>
+        </pc:spChg>
+        <pc:spChg chg="mod">
+          <ac:chgData name="Raghavendra Angara" userId="6b971708-5412-4b70-9031-36da4ebff12f" providerId="ADAL" clId="{FF26F244-2771-4A64-A430-D1400A5380B4}" dt="2026-03-06T05:08:30.248" v="190" actId="20577"/>
+          <ac:spMkLst>
+            <pc:docMk/>
+            <pc:sldMk cId="0" sldId="260"/>
+            <ac:spMk id="29" creationId="{00000000-0000-0000-0000-000000000000}"/>
+          </ac:spMkLst>
+        </pc:spChg>
+        <pc:spChg chg="mod">
+          <ac:chgData name="Raghavendra Angara" userId="6b971708-5412-4b70-9031-36da4ebff12f" providerId="ADAL" clId="{FF26F244-2771-4A64-A430-D1400A5380B4}" dt="2026-03-06T05:06:56.019" v="179" actId="1076"/>
+          <ac:spMkLst>
+            <pc:docMk/>
+            <pc:sldMk cId="0" sldId="260"/>
+            <ac:spMk id="31" creationId="{00000000-0000-0000-0000-000000000000}"/>
+          </ac:spMkLst>
+        </pc:spChg>
+        <pc:spChg chg="del mod">
+          <ac:chgData name="Raghavendra Angara" userId="6b971708-5412-4b70-9031-36da4ebff12f" providerId="ADAL" clId="{FF26F244-2771-4A64-A430-D1400A5380B4}" dt="2026-03-06T05:10:04.276" v="210" actId="478"/>
+          <ac:spMkLst>
+            <pc:docMk/>
+            <pc:sldMk cId="0" sldId="260"/>
+            <ac:spMk id="32" creationId="{00000000-0000-0000-0000-000000000000}"/>
+          </ac:spMkLst>
+        </pc:spChg>
+        <pc:spChg chg="mod">
+          <ac:chgData name="Raghavendra Angara" userId="6b971708-5412-4b70-9031-36da4ebff12f" providerId="ADAL" clId="{FF26F244-2771-4A64-A430-D1400A5380B4}" dt="2026-03-06T05:08:48.571" v="197" actId="14100"/>
+          <ac:spMkLst>
+            <pc:docMk/>
+            <pc:sldMk cId="0" sldId="260"/>
+            <ac:spMk id="33" creationId="{00000000-0000-0000-0000-000000000000}"/>
+          </ac:spMkLst>
+        </pc:spChg>
+        <pc:spChg chg="mod">
+          <ac:chgData name="Raghavendra Angara" userId="6b971708-5412-4b70-9031-36da4ebff12f" providerId="ADAL" clId="{FF26F244-2771-4A64-A430-D1400A5380B4}" dt="2026-03-06T05:08:40.439" v="196" actId="1038"/>
+          <ac:spMkLst>
+            <pc:docMk/>
+            <pc:sldMk cId="0" sldId="260"/>
+            <ac:spMk id="34" creationId="{00000000-0000-0000-0000-000000000000}"/>
+          </ac:spMkLst>
+        </pc:spChg>
+        <pc:spChg chg="mod">
+          <ac:chgData name="Raghavendra Angara" userId="6b971708-5412-4b70-9031-36da4ebff12f" providerId="ADAL" clId="{FF26F244-2771-4A64-A430-D1400A5380B4}" dt="2026-03-06T05:09:39.731" v="206" actId="20577"/>
+          <ac:spMkLst>
+            <pc:docMk/>
+            <pc:sldMk cId="0" sldId="260"/>
+            <ac:spMk id="35" creationId="{00000000-0000-0000-0000-000000000000}"/>
+          </ac:spMkLst>
+        </pc:spChg>
+        <pc:spChg chg="mod">
+          <ac:chgData name="Raghavendra Angara" userId="6b971708-5412-4b70-9031-36da4ebff12f" providerId="ADAL" clId="{FF26F244-2771-4A64-A430-D1400A5380B4}" dt="2026-03-06T05:08:40.439" v="196" actId="1038"/>
+          <ac:spMkLst>
+            <pc:docMk/>
+            <pc:sldMk cId="0" sldId="260"/>
+            <ac:spMk id="36" creationId="{00000000-0000-0000-0000-000000000000}"/>
+          </ac:spMkLst>
+        </pc:spChg>
+        <pc:spChg chg="mod">
+          <ac:chgData name="Raghavendra Angara" userId="6b971708-5412-4b70-9031-36da4ebff12f" providerId="ADAL" clId="{FF26F244-2771-4A64-A430-D1400A5380B4}" dt="2026-03-06T05:08:40.439" v="196" actId="1038"/>
+          <ac:spMkLst>
+            <pc:docMk/>
+            <pc:sldMk cId="0" sldId="260"/>
+            <ac:spMk id="37" creationId="{00000000-0000-0000-0000-000000000000}"/>
+          </ac:spMkLst>
+        </pc:spChg>
+        <pc:spChg chg="del mod">
+          <ac:chgData name="Raghavendra Angara" userId="6b971708-5412-4b70-9031-36da4ebff12f" providerId="ADAL" clId="{FF26F244-2771-4A64-A430-D1400A5380B4}" dt="2026-03-06T05:10:02.973" v="209" actId="478"/>
+          <ac:spMkLst>
+            <pc:docMk/>
+            <pc:sldMk cId="0" sldId="260"/>
+            <ac:spMk id="38" creationId="{00000000-0000-0000-0000-000000000000}"/>
+          </ac:spMkLst>
+        </pc:spChg>
+        <pc:spChg chg="mod">
+          <ac:chgData name="Raghavendra Angara" userId="6b971708-5412-4b70-9031-36da4ebff12f" providerId="ADAL" clId="{FF26F244-2771-4A64-A430-D1400A5380B4}" dt="2026-03-06T05:10:30.377" v="218" actId="14100"/>
+          <ac:spMkLst>
+            <pc:docMk/>
+            <pc:sldMk cId="0" sldId="260"/>
+            <ac:spMk id="39" creationId="{00000000-0000-0000-0000-000000000000}"/>
+          </ac:spMkLst>
+        </pc:spChg>
+        <pc:spChg chg="mod">
+          <ac:chgData name="Raghavendra Angara" userId="6b971708-5412-4b70-9031-36da4ebff12f" providerId="ADAL" clId="{FF26F244-2771-4A64-A430-D1400A5380B4}" dt="2026-03-06T05:10:27.101" v="217" actId="1038"/>
+          <ac:spMkLst>
+            <pc:docMk/>
+            <pc:sldMk cId="0" sldId="260"/>
+            <ac:spMk id="40" creationId="{00000000-0000-0000-0000-000000000000}"/>
+          </ac:spMkLst>
+        </pc:spChg>
+        <pc:spChg chg="mod">
+          <ac:chgData name="Raghavendra Angara" userId="6b971708-5412-4b70-9031-36da4ebff12f" providerId="ADAL" clId="{FF26F244-2771-4A64-A430-D1400A5380B4}" dt="2026-03-06T05:10:27.101" v="217" actId="1038"/>
+          <ac:spMkLst>
+            <pc:docMk/>
+            <pc:sldMk cId="0" sldId="260"/>
+            <ac:spMk id="41" creationId="{00000000-0000-0000-0000-000000000000}"/>
+          </ac:spMkLst>
+        </pc:spChg>
+        <pc:spChg chg="mod">
+          <ac:chgData name="Raghavendra Angara" userId="6b971708-5412-4b70-9031-36da4ebff12f" providerId="ADAL" clId="{FF26F244-2771-4A64-A430-D1400A5380B4}" dt="2026-03-06T05:10:27.101" v="217" actId="1038"/>
+          <ac:spMkLst>
+            <pc:docMk/>
+            <pc:sldMk cId="0" sldId="260"/>
+            <ac:spMk id="42" creationId="{00000000-0000-0000-0000-000000000000}"/>
+          </ac:spMkLst>
+        </pc:spChg>
+        <pc:spChg chg="mod">
+          <ac:chgData name="Raghavendra Angara" userId="6b971708-5412-4b70-9031-36da4ebff12f" providerId="ADAL" clId="{FF26F244-2771-4A64-A430-D1400A5380B4}" dt="2026-03-06T05:10:27.101" v="217" actId="1038"/>
+          <ac:spMkLst>
+            <pc:docMk/>
+            <pc:sldMk cId="0" sldId="260"/>
+            <ac:spMk id="43" creationId="{00000000-0000-0000-0000-000000000000}"/>
+          </ac:spMkLst>
+        </pc:spChg>
+        <pc:spChg chg="del">
+          <ac:chgData name="Raghavendra Angara" userId="6b971708-5412-4b70-9031-36da4ebff12f" providerId="ADAL" clId="{FF26F244-2771-4A64-A430-D1400A5380B4}" dt="2026-03-06T05:08:31.948" v="191" actId="478"/>
+          <ac:spMkLst>
+            <pc:docMk/>
+            <pc:sldMk cId="0" sldId="260"/>
+            <ac:spMk id="44" creationId="{00000000-0000-0000-0000-000000000000}"/>
+          </ac:spMkLst>
+        </pc:spChg>
+        <pc:spChg chg="del">
+          <ac:chgData name="Raghavendra Angara" userId="6b971708-5412-4b70-9031-36da4ebff12f" providerId="ADAL" clId="{FF26F244-2771-4A64-A430-D1400A5380B4}" dt="2026-03-06T05:08:33.772" v="192" actId="478"/>
+          <ac:spMkLst>
+            <pc:docMk/>
+            <pc:sldMk cId="0" sldId="260"/>
+            <ac:spMk id="45" creationId="{00000000-0000-0000-0000-000000000000}"/>
+          </ac:spMkLst>
+        </pc:spChg>
+        <pc:spChg chg="mod">
+          <ac:chgData name="Raghavendra Angara" userId="6b971708-5412-4b70-9031-36da4ebff12f" providerId="ADAL" clId="{FF26F244-2771-4A64-A430-D1400A5380B4}" dt="2026-03-06T05:09:29.908" v="204" actId="1076"/>
+          <ac:spMkLst>
+            <pc:docMk/>
+            <pc:sldMk cId="0" sldId="260"/>
+            <ac:spMk id="46" creationId="{00000000-0000-0000-0000-000000000000}"/>
+          </ac:spMkLst>
+        </pc:spChg>
+        <pc:spChg chg="mod">
+          <ac:chgData name="Raghavendra Angara" userId="6b971708-5412-4b70-9031-36da4ebff12f" providerId="ADAL" clId="{FF26F244-2771-4A64-A430-D1400A5380B4}" dt="2026-03-06T05:09:29.908" v="204" actId="1076"/>
+          <ac:spMkLst>
+            <pc:docMk/>
+            <pc:sldMk cId="0" sldId="260"/>
+            <ac:spMk id="47" creationId="{00000000-0000-0000-0000-000000000000}"/>
+          </ac:spMkLst>
+        </pc:spChg>
+        <pc:spChg chg="mod">
+          <ac:chgData name="Raghavendra Angara" userId="6b971708-5412-4b70-9031-36da4ebff12f" providerId="ADAL" clId="{FF26F244-2771-4A64-A430-D1400A5380B4}" dt="2026-03-06T05:09:29.908" v="204" actId="1076"/>
+          <ac:spMkLst>
+            <pc:docMk/>
+            <pc:sldMk cId="0" sldId="260"/>
+            <ac:spMk id="48" creationId="{00000000-0000-0000-0000-000000000000}"/>
+          </ac:spMkLst>
+        </pc:spChg>
+        <pc:spChg chg="mod">
+          <ac:chgData name="Raghavendra Angara" userId="6b971708-5412-4b70-9031-36da4ebff12f" providerId="ADAL" clId="{FF26F244-2771-4A64-A430-D1400A5380B4}" dt="2026-03-06T05:09:29.908" v="204" actId="1076"/>
+          <ac:spMkLst>
+            <pc:docMk/>
+            <pc:sldMk cId="0" sldId="260"/>
+            <ac:spMk id="49" creationId="{00000000-0000-0000-0000-000000000000}"/>
+          </ac:spMkLst>
+        </pc:spChg>
+        <pc:spChg chg="mod">
+          <ac:chgData name="Raghavendra Angara" userId="6b971708-5412-4b70-9031-36da4ebff12f" providerId="ADAL" clId="{FF26F244-2771-4A64-A430-D1400A5380B4}" dt="2026-03-06T05:09:25.504" v="203" actId="1076"/>
+          <ac:spMkLst>
+            <pc:docMk/>
+            <pc:sldMk cId="0" sldId="260"/>
+            <ac:spMk id="50" creationId="{00000000-0000-0000-0000-000000000000}"/>
+          </ac:spMkLst>
+        </pc:spChg>
+        <pc:spChg chg="mod">
+          <ac:chgData name="Raghavendra Angara" userId="6b971708-5412-4b70-9031-36da4ebff12f" providerId="ADAL" clId="{FF26F244-2771-4A64-A430-D1400A5380B4}" dt="2026-03-06T05:09:25.504" v="203" actId="1076"/>
+          <ac:spMkLst>
+            <pc:docMk/>
+            <pc:sldMk cId="0" sldId="260"/>
+            <ac:spMk id="51" creationId="{00000000-0000-0000-0000-000000000000}"/>
+          </ac:spMkLst>
+        </pc:spChg>
+        <pc:spChg chg="mod">
+          <ac:chgData name="Raghavendra Angara" userId="6b971708-5412-4b70-9031-36da4ebff12f" providerId="ADAL" clId="{FF26F244-2771-4A64-A430-D1400A5380B4}" dt="2026-03-06T05:09:25.504" v="203" actId="1076"/>
+          <ac:spMkLst>
+            <pc:docMk/>
+            <pc:sldMk cId="0" sldId="260"/>
+            <ac:spMk id="52" creationId="{00000000-0000-0000-0000-000000000000}"/>
+          </ac:spMkLst>
+        </pc:spChg>
+        <pc:spChg chg="mod">
+          <ac:chgData name="Raghavendra Angara" userId="6b971708-5412-4b70-9031-36da4ebff12f" providerId="ADAL" clId="{FF26F244-2771-4A64-A430-D1400A5380B4}" dt="2026-03-06T05:09:25.504" v="203" actId="1076"/>
+          <ac:spMkLst>
+            <pc:docMk/>
+            <pc:sldMk cId="0" sldId="260"/>
+            <ac:spMk id="53" creationId="{00000000-0000-0000-0000-000000000000}"/>
+          </ac:spMkLst>
+        </pc:spChg>
+        <pc:spChg chg="mod">
+          <ac:chgData name="Raghavendra Angara" userId="6b971708-5412-4b70-9031-36da4ebff12f" providerId="ADAL" clId="{FF26F244-2771-4A64-A430-D1400A5380B4}" dt="2026-03-06T05:09:25.504" v="203" actId="1076"/>
+          <ac:spMkLst>
+            <pc:docMk/>
+            <pc:sldMk cId="0" sldId="260"/>
+            <ac:spMk id="54" creationId="{00000000-0000-0000-0000-000000000000}"/>
+          </ac:spMkLst>
+        </pc:spChg>
+        <pc:spChg chg="mod">
+          <ac:chgData name="Raghavendra Angara" userId="6b971708-5412-4b70-9031-36da4ebff12f" providerId="ADAL" clId="{FF26F244-2771-4A64-A430-D1400A5380B4}" dt="2026-03-06T05:09:25.504" v="203" actId="1076"/>
+          <ac:spMkLst>
+            <pc:docMk/>
+            <pc:sldMk cId="0" sldId="260"/>
+            <ac:spMk id="55" creationId="{00000000-0000-0000-0000-000000000000}"/>
+          </ac:spMkLst>
+        </pc:spChg>
+        <pc:spChg chg="mod">
+          <ac:chgData name="Raghavendra Angara" userId="6b971708-5412-4b70-9031-36da4ebff12f" providerId="ADAL" clId="{FF26F244-2771-4A64-A430-D1400A5380B4}" dt="2026-03-06T05:09:25.504" v="203" actId="1076"/>
+          <ac:spMkLst>
+            <pc:docMk/>
+            <pc:sldMk cId="0" sldId="260"/>
+            <ac:spMk id="56" creationId="{00000000-0000-0000-0000-000000000000}"/>
+          </ac:spMkLst>
+        </pc:spChg>
+        <pc:spChg chg="mod">
+          <ac:chgData name="Raghavendra Angara" userId="6b971708-5412-4b70-9031-36da4ebff12f" providerId="ADAL" clId="{FF26F244-2771-4A64-A430-D1400A5380B4}" dt="2026-03-06T05:09:25.504" v="203" actId="1076"/>
+          <ac:spMkLst>
+            <pc:docMk/>
+            <pc:sldMk cId="0" sldId="260"/>
+            <ac:spMk id="57" creationId="{00000000-0000-0000-0000-000000000000}"/>
+          </ac:spMkLst>
+        </pc:spChg>
+      </pc:sldChg>
+      <pc:sldChg chg="delSp modSp mod">
+        <pc:chgData name="Raghavendra Angara" userId="6b971708-5412-4b70-9031-36da4ebff12f" providerId="ADAL" clId="{FF26F244-2771-4A64-A430-D1400A5380B4}" dt="2026-03-06T05:13:58.365" v="232" actId="14100"/>
+        <pc:sldMkLst>
+          <pc:docMk/>
+          <pc:sldMk cId="0" sldId="263"/>
+        </pc:sldMkLst>
+        <pc:spChg chg="mod">
+          <ac:chgData name="Raghavendra Angara" userId="6b971708-5412-4b70-9031-36da4ebff12f" providerId="ADAL" clId="{FF26F244-2771-4A64-A430-D1400A5380B4}" dt="2026-03-06T05:13:49.560" v="230" actId="14100"/>
+          <ac:spMkLst>
+            <pc:docMk/>
+            <pc:sldMk cId="0" sldId="263"/>
+            <ac:spMk id="5" creationId="{00000000-0000-0000-0000-000000000000}"/>
+          </ac:spMkLst>
+        </pc:spChg>
+        <pc:spChg chg="del">
+          <ac:chgData name="Raghavendra Angara" userId="6b971708-5412-4b70-9031-36da4ebff12f" providerId="ADAL" clId="{FF26F244-2771-4A64-A430-D1400A5380B4}" dt="2026-03-06T05:13:18.745" v="223" actId="478"/>
+          <ac:spMkLst>
+            <pc:docMk/>
+            <pc:sldMk cId="0" sldId="263"/>
+            <ac:spMk id="27" creationId="{00000000-0000-0000-0000-000000000000}"/>
+          </ac:spMkLst>
+        </pc:spChg>
+        <pc:spChg chg="del">
+          <ac:chgData name="Raghavendra Angara" userId="6b971708-5412-4b70-9031-36da4ebff12f" providerId="ADAL" clId="{FF26F244-2771-4A64-A430-D1400A5380B4}" dt="2026-03-06T05:13:25.756" v="224" actId="478"/>
+          <ac:spMkLst>
+            <pc:docMk/>
+            <pc:sldMk cId="0" sldId="263"/>
+            <ac:spMk id="28" creationId="{00000000-0000-0000-0000-000000000000}"/>
+          </ac:spMkLst>
+        </pc:spChg>
+        <pc:spChg chg="mod">
+          <ac:chgData name="Raghavendra Angara" userId="6b971708-5412-4b70-9031-36da4ebff12f" providerId="ADAL" clId="{FF26F244-2771-4A64-A430-D1400A5380B4}" dt="2026-03-06T05:13:45.746" v="229" actId="14100"/>
+          <ac:spMkLst>
+            <pc:docMk/>
+            <pc:sldMk cId="0" sldId="263"/>
+            <ac:spMk id="29" creationId="{00000000-0000-0000-0000-000000000000}"/>
+          </ac:spMkLst>
+        </pc:spChg>
+        <pc:spChg chg="del">
+          <ac:chgData name="Raghavendra Angara" userId="6b971708-5412-4b70-9031-36da4ebff12f" providerId="ADAL" clId="{FF26F244-2771-4A64-A430-D1400A5380B4}" dt="2026-03-06T05:13:37.125" v="228" actId="478"/>
+          <ac:spMkLst>
+            <pc:docMk/>
+            <pc:sldMk cId="0" sldId="263"/>
+            <ac:spMk id="51" creationId="{00000000-0000-0000-0000-000000000000}"/>
+          </ac:spMkLst>
+        </pc:spChg>
+        <pc:spChg chg="del">
+          <ac:chgData name="Raghavendra Angara" userId="6b971708-5412-4b70-9031-36da4ebff12f" providerId="ADAL" clId="{FF26F244-2771-4A64-A430-D1400A5380B4}" dt="2026-03-06T05:13:28.823" v="225" actId="478"/>
+          <ac:spMkLst>
+            <pc:docMk/>
+            <pc:sldMk cId="0" sldId="263"/>
+            <ac:spMk id="52" creationId="{00000000-0000-0000-0000-000000000000}"/>
+          </ac:spMkLst>
+        </pc:spChg>
+        <pc:spChg chg="mod">
+          <ac:chgData name="Raghavendra Angara" userId="6b971708-5412-4b70-9031-36da4ebff12f" providerId="ADAL" clId="{FF26F244-2771-4A64-A430-D1400A5380B4}" dt="2026-03-06T05:13:53.755" v="231" actId="14100"/>
+          <ac:spMkLst>
+            <pc:docMk/>
+            <pc:sldMk cId="0" sldId="263"/>
+            <ac:spMk id="53" creationId="{00000000-0000-0000-0000-000000000000}"/>
+          </ac:spMkLst>
+        </pc:spChg>
+        <pc:spChg chg="del">
+          <ac:chgData name="Raghavendra Angara" userId="6b971708-5412-4b70-9031-36da4ebff12f" providerId="ADAL" clId="{FF26F244-2771-4A64-A430-D1400A5380B4}" dt="2026-03-06T05:13:35.988" v="227" actId="478"/>
+          <ac:spMkLst>
+            <pc:docMk/>
+            <pc:sldMk cId="0" sldId="263"/>
+            <ac:spMk id="75" creationId="{00000000-0000-0000-0000-000000000000}"/>
+          </ac:spMkLst>
+        </pc:spChg>
+        <pc:spChg chg="del">
+          <ac:chgData name="Raghavendra Angara" userId="6b971708-5412-4b70-9031-36da4ebff12f" providerId="ADAL" clId="{FF26F244-2771-4A64-A430-D1400A5380B4}" dt="2026-03-06T05:13:34.607" v="226" actId="478"/>
+          <ac:spMkLst>
+            <pc:docMk/>
+            <pc:sldMk cId="0" sldId="263"/>
+            <ac:spMk id="76" creationId="{00000000-0000-0000-0000-000000000000}"/>
+          </ac:spMkLst>
+        </pc:spChg>
+        <pc:spChg chg="mod">
+          <ac:chgData name="Raghavendra Angara" userId="6b971708-5412-4b70-9031-36da4ebff12f" providerId="ADAL" clId="{FF26F244-2771-4A64-A430-D1400A5380B4}" dt="2026-03-06T05:13:58.365" v="232" actId="14100"/>
+          <ac:spMkLst>
+            <pc:docMk/>
+            <pc:sldMk cId="0" sldId="263"/>
+            <ac:spMk id="77" creationId="{00000000-0000-0000-0000-000000000000}"/>
+          </ac:spMkLst>
+        </pc:spChg>
+      </pc:sldChg>
+      <pc:sldChg chg="modSp mod">
+        <pc:chgData name="Raghavendra Angara" userId="6b971708-5412-4b70-9031-36da4ebff12f" providerId="ADAL" clId="{FF26F244-2771-4A64-A430-D1400A5380B4}" dt="2026-03-06T05:11:42.025" v="222" actId="6549"/>
+        <pc:sldMkLst>
+          <pc:docMk/>
+          <pc:sldMk cId="0" sldId="264"/>
+        </pc:sldMkLst>
+        <pc:spChg chg="mod">
+          <ac:chgData name="Raghavendra Angara" userId="6b971708-5412-4b70-9031-36da4ebff12f" providerId="ADAL" clId="{FF26F244-2771-4A64-A430-D1400A5380B4}" dt="2026-03-06T05:11:33.185" v="219" actId="6549"/>
+          <ac:spMkLst>
+            <pc:docMk/>
+            <pc:sldMk cId="0" sldId="264"/>
+            <ac:spMk id="6" creationId="{00000000-0000-0000-0000-000000000000}"/>
+          </ac:spMkLst>
+        </pc:spChg>
+        <pc:spChg chg="mod">
+          <ac:chgData name="Raghavendra Angara" userId="6b971708-5412-4b70-9031-36da4ebff12f" providerId="ADAL" clId="{FF26F244-2771-4A64-A430-D1400A5380B4}" dt="2026-03-06T05:11:42.025" v="222" actId="6549"/>
+          <ac:spMkLst>
+            <pc:docMk/>
+            <pc:sldMk cId="0" sldId="264"/>
+            <ac:spMk id="17" creationId="{00000000-0000-0000-0000-000000000000}"/>
+          </ac:spMkLst>
+        </pc:spChg>
+        <pc:spChg chg="mod">
+          <ac:chgData name="Raghavendra Angara" userId="6b971708-5412-4b70-9031-36da4ebff12f" providerId="ADAL" clId="{FF26F244-2771-4A64-A430-D1400A5380B4}" dt="2026-03-06T05:11:39.977" v="221" actId="6549"/>
+          <ac:spMkLst>
+            <pc:docMk/>
+            <pc:sldMk cId="0" sldId="264"/>
+            <ac:spMk id="28" creationId="{00000000-0000-0000-0000-000000000000}"/>
+          </ac:spMkLst>
+        </pc:spChg>
+      </pc:sldChg>
+      <pc:sldChg chg="addSp delSp new add del mod">
+        <pc:chgData name="Raghavendra Angara" userId="6b971708-5412-4b70-9031-36da4ebff12f" providerId="ADAL" clId="{FF26F244-2771-4A64-A430-D1400A5380B4}" dt="2026-03-06T02:19:49.011" v="37" actId="2696"/>
+        <pc:sldMkLst>
+          <pc:docMk/>
+          <pc:sldMk cId="2205427204" sldId="266"/>
+        </pc:sldMkLst>
+        <pc:spChg chg="add del">
+          <ac:chgData name="Raghavendra Angara" userId="6b971708-5412-4b70-9031-36da4ebff12f" providerId="ADAL" clId="{FF26F244-2771-4A64-A430-D1400A5380B4}" dt="2026-03-06T02:10:56.066" v="19" actId="22"/>
+          <ac:spMkLst>
+            <pc:docMk/>
+            <pc:sldMk cId="2205427204" sldId="266"/>
+            <ac:spMk id="3" creationId="{EFC1B892-7E96-7388-BF77-6005C5BE21F2}"/>
+          </ac:spMkLst>
+        </pc:spChg>
+        <pc:spChg chg="add del">
+          <ac:chgData name="Raghavendra Angara" userId="6b971708-5412-4b70-9031-36da4ebff12f" providerId="ADAL" clId="{FF26F244-2771-4A64-A430-D1400A5380B4}" dt="2026-03-06T02:12:50.803" v="21" actId="478"/>
+          <ac:spMkLst>
+            <pc:docMk/>
+            <pc:sldMk cId="2205427204" sldId="266"/>
+            <ac:spMk id="5" creationId="{D362C646-1A6C-9653-257C-A4837C97F335}"/>
           </ac:spMkLst>
         </pc:spChg>
       </pc:sldChg>
@@ -1877,7 +2734,7 @@
                 <a:ea typeface="Consolas" pitchFamily="34" charset="-122"/>
                 <a:cs typeface="Consolas" pitchFamily="34" charset="-120"/>
               </a:rPr>
-              <a:t>AI TRANSLATION STRATEGY REPORT</a:t>
+              <a:t>AI TRANSLATION STRATEGY</a:t>
             </a:r>
             <a:endParaRPr lang="en-US" sz="800" dirty="0"/>
           </a:p>
@@ -1891,7 +2748,7 @@
         </p:nvSpPr>
         <p:spPr>
           <a:xfrm>
-            <a:off x="548640" y="822960"/>
+            <a:off x="484632" y="591195"/>
             <a:ext cx="6400800" cy="1828800"/>
           </a:xfrm>
           <a:prstGeom prst="rect">
@@ -1923,62 +2780,42 @@
             </a:r>
             <a:endParaRPr lang="en-US" sz="4400" dirty="0"/>
           </a:p>
-          <a:p>
-            <a:pPr marL="0" indent="0">
-              <a:lnSpc>
-                <a:spcPct val="110000"/>
-              </a:lnSpc>
+        </p:txBody>
+      </p:sp>
+      <p:sp>
+        <p:nvSpPr>
+          <p:cNvPr id="6" name="Text 4"/>
+          <p:cNvSpPr/>
+          <p:nvPr/>
+        </p:nvSpPr>
+        <p:spPr>
+          <a:xfrm>
+            <a:off x="512064" y="1768133"/>
+            <a:ext cx="6400800" cy="822960"/>
+          </a:xfrm>
+          <a:prstGeom prst="rect">
+            <a:avLst/>
+          </a:prstGeom>
+          <a:noFill/>
+          <a:ln/>
+        </p:spPr>
+        <p:txBody>
+          <a:bodyPr wrap="square" rtlCol="0" anchor="ctr"/>
+          <a:lstStyle/>
+          <a:p>
+            <a:pPr marL="0" indent="0">
               <a:buNone/>
             </a:pPr>
             <a:r>
               <a:rPr lang="en-US" sz="4400" b="1" dirty="0">
                 <a:solidFill>
-                  <a:srgbClr val="E8E8F0"/>
+                  <a:srgbClr val="00D4A0"/>
                 </a:solidFill>
                 <a:latin typeface="Calibri" pitchFamily="34" charset="0"/>
                 <a:ea typeface="Calibri" pitchFamily="34" charset="-122"/>
                 <a:cs typeface="Calibri" pitchFamily="34" charset="-120"/>
               </a:rPr>
-              <a:t>Engine Selection</a:t>
-            </a:r>
-            <a:endParaRPr lang="en-US" sz="4400" dirty="0"/>
-          </a:p>
-        </p:txBody>
-      </p:sp>
-      <p:sp>
-        <p:nvSpPr>
-          <p:cNvPr id="6" name="Text 4"/>
-          <p:cNvSpPr/>
-          <p:nvPr/>
-        </p:nvSpPr>
-        <p:spPr>
-          <a:xfrm>
-            <a:off x="548640" y="1783080"/>
-            <a:ext cx="6400800" cy="822960"/>
-          </a:xfrm>
-          <a:prstGeom prst="rect">
-            <a:avLst/>
-          </a:prstGeom>
-          <a:noFill/>
-          <a:ln/>
-        </p:spPr>
-        <p:txBody>
-          <a:bodyPr wrap="square" rtlCol="0" anchor="ctr"/>
-          <a:lstStyle/>
-          <a:p>
-            <a:pPr marL="0" indent="0">
-              <a:buNone/>
-            </a:pPr>
-            <a:r>
-              <a:rPr lang="en-US" sz="4400" b="1" dirty="0">
-                <a:solidFill>
-                  <a:srgbClr val="00D4A0"/>
-                </a:solidFill>
-                <a:latin typeface="Calibri" pitchFamily="34" charset="0"/>
-                <a:ea typeface="Calibri" pitchFamily="34" charset="-122"/>
-                <a:cs typeface="Calibri" pitchFamily="34" charset="-120"/>
-              </a:rPr>
-              <a:t>Engine Selection</a:t>
+              <a:t>Engine Evolution</a:t>
             </a:r>
             <a:endParaRPr lang="en-US" sz="4400" dirty="0"/>
           </a:p>
@@ -2016,13 +2853,15 @@
                 <a:solidFill>
                   <a:srgbClr val="8888AA"/>
                 </a:solidFill>
-                <a:latin typeface="Calibri" pitchFamily="34" charset="0"/>
+                <a:latin typeface="Consolas" panose="020B0609020204030204" pitchFamily="49" charset="0"/>
                 <a:ea typeface="Calibri" pitchFamily="34" charset="-122"/>
                 <a:cs typeface="Calibri" pitchFamily="34" charset="-120"/>
               </a:rPr>
-              <a:t>Accuracy · Language Coverage · Cost · Architecture</a:t>
-            </a:r>
-            <a:endParaRPr lang="en-US" sz="1300" dirty="0"/>
+              <a:t>Accuracy · Language Coverage · Cost ·</a:t>
+            </a:r>
+            <a:endParaRPr lang="en-US" sz="1300" dirty="0">
+              <a:latin typeface="Consolas" panose="020B0609020204030204" pitchFamily="49" charset="0"/>
+            </a:endParaRPr>
           </a:p>
           <a:p>
             <a:pPr marL="0" indent="0">
@@ -2036,13 +2875,15 @@
                 <a:solidFill>
                   <a:srgbClr val="8888AA"/>
                 </a:solidFill>
-                <a:latin typeface="Calibri" pitchFamily="34" charset="0"/>
+                <a:latin typeface="Consolas" panose="020B0609020204030204" pitchFamily="49" charset="0"/>
                 <a:ea typeface="Calibri" pitchFamily="34" charset="-122"/>
                 <a:cs typeface="Calibri" pitchFamily="34" charset="-120"/>
               </a:rPr>
-              <a:t>Full evaluation for AI-powered multilingual storefront</a:t>
-            </a:r>
-            <a:endParaRPr lang="en-US" sz="1300" dirty="0"/>
+              <a:t>Full evaluation for AI-powered translation Architecture</a:t>
+            </a:r>
+            <a:endParaRPr lang="en-US" sz="1300" dirty="0">
+              <a:latin typeface="Consolas" panose="020B0609020204030204" pitchFamily="49" charset="0"/>
+            </a:endParaRPr>
           </a:p>
         </p:txBody>
       </p:sp>
@@ -2667,15 +3508,14 @@
               <a:buNone/>
             </a:pPr>
             <a:r>
-              <a:rPr lang="en-US" sz="800" dirty="0">
-                <a:solidFill>
-                  <a:srgbClr val="555577"/>
-                </a:solidFill>
-                <a:latin typeface="Consolas" pitchFamily="34" charset="0"/>
-                <a:ea typeface="Consolas" pitchFamily="34" charset="-122"/>
-                <a:cs typeface="Consolas" pitchFamily="34" charset="-120"/>
-              </a:rPr>
-              <a:t>Prices as of early 2025 — verify current rates with providers</a:t>
+              <a:rPr lang="en-US" sz="800" b="0" i="0" dirty="0">
+                <a:solidFill>
+                  <a:srgbClr val="8891AA"/>
+                </a:solidFill>
+                <a:effectLst/>
+                <a:latin typeface="DM Mono" panose="020B0509040201040103" pitchFamily="49" charset="0"/>
+              </a:rPr>
+              <a:t>Prices are approximate — verify current rates with providers</a:t>
             </a:r>
             <a:endParaRPr lang="en-US" sz="800" dirty="0"/>
           </a:p>
@@ -4554,7 +5394,7 @@
         </p:nvSpPr>
         <p:spPr>
           <a:xfrm>
-            <a:off x="4663440" y="1463040"/>
+            <a:off x="4663440" y="1480624"/>
             <a:ext cx="731520" cy="64008"/>
           </a:xfrm>
           <a:prstGeom prst="rect">
@@ -4957,7 +5797,7 @@
         </p:nvSpPr>
         <p:spPr>
           <a:xfrm>
-            <a:off x="2423160" y="2048256"/>
+            <a:off x="2423160" y="2074632"/>
             <a:ext cx="1005840" cy="64008"/>
           </a:xfrm>
           <a:prstGeom prst="rect">
@@ -4989,7 +5829,7 @@
         </p:nvSpPr>
         <p:spPr>
           <a:xfrm>
-            <a:off x="2423160" y="2048256"/>
+            <a:off x="2423160" y="2074632"/>
             <a:ext cx="915314" cy="64008"/>
           </a:xfrm>
           <a:prstGeom prst="rect">
@@ -5060,7 +5900,7 @@
         </p:nvSpPr>
         <p:spPr>
           <a:xfrm>
-            <a:off x="2423160" y="2322576"/>
+            <a:off x="2423160" y="2348952"/>
             <a:ext cx="1005840" cy="64008"/>
           </a:xfrm>
           <a:prstGeom prst="rect">
@@ -5092,7 +5932,7 @@
         </p:nvSpPr>
         <p:spPr>
           <a:xfrm>
-            <a:off x="2423160" y="2322576"/>
+            <a:off x="2423160" y="2348952"/>
             <a:ext cx="854964" cy="64008"/>
           </a:xfrm>
           <a:prstGeom prst="rect">
@@ -5234,7 +6074,7 @@
         </p:nvSpPr>
         <p:spPr>
           <a:xfrm>
-            <a:off x="4663440" y="2148840"/>
+            <a:off x="4663440" y="2175216"/>
             <a:ext cx="724205" cy="64008"/>
           </a:xfrm>
           <a:prstGeom prst="rect">
@@ -5605,7 +6445,7 @@
         </p:nvSpPr>
         <p:spPr>
           <a:xfrm>
-            <a:off x="2423160" y="2734056"/>
+            <a:off x="2423160" y="2760432"/>
             <a:ext cx="1005840" cy="64008"/>
           </a:xfrm>
           <a:prstGeom prst="rect">
@@ -5637,7 +6477,7 @@
         </p:nvSpPr>
         <p:spPr>
           <a:xfrm>
-            <a:off x="2423160" y="2734056"/>
+            <a:off x="2423160" y="2760432"/>
             <a:ext cx="965606" cy="64008"/>
           </a:xfrm>
           <a:prstGeom prst="rect">
@@ -5708,7 +6548,7 @@
         </p:nvSpPr>
         <p:spPr>
           <a:xfrm>
-            <a:off x="2423160" y="3008376"/>
+            <a:off x="2423160" y="3034752"/>
             <a:ext cx="1005840" cy="64008"/>
           </a:xfrm>
           <a:prstGeom prst="rect">
@@ -5740,7 +6580,7 @@
         </p:nvSpPr>
         <p:spPr>
           <a:xfrm>
-            <a:off x="2423160" y="3008376"/>
+            <a:off x="2423160" y="3034752"/>
             <a:ext cx="975665" cy="64008"/>
           </a:xfrm>
           <a:prstGeom prst="rect">
@@ -5850,7 +6690,7 @@
         </p:nvSpPr>
         <p:spPr>
           <a:xfrm>
-            <a:off x="4663440" y="2834640"/>
+            <a:off x="4663440" y="2852224"/>
             <a:ext cx="731520" cy="64008"/>
           </a:xfrm>
           <a:prstGeom prst="rect">
@@ -5882,7 +6722,7 @@
         </p:nvSpPr>
         <p:spPr>
           <a:xfrm>
-            <a:off x="4663440" y="2834640"/>
+            <a:off x="4663440" y="2852224"/>
             <a:ext cx="512064" cy="64008"/>
           </a:xfrm>
           <a:prstGeom prst="rect">
@@ -6253,7 +7093,7 @@
         </p:nvSpPr>
         <p:spPr>
           <a:xfrm>
-            <a:off x="2423160" y="3419856"/>
+            <a:off x="2423160" y="3455024"/>
             <a:ext cx="1005840" cy="64008"/>
           </a:xfrm>
           <a:prstGeom prst="rect">
@@ -6285,7 +7125,7 @@
         </p:nvSpPr>
         <p:spPr>
           <a:xfrm>
-            <a:off x="2423160" y="3419856"/>
+            <a:off x="2423160" y="3455024"/>
             <a:ext cx="905256" cy="64008"/>
           </a:xfrm>
           <a:prstGeom prst="rect">
@@ -6356,7 +7196,7 @@
         </p:nvSpPr>
         <p:spPr>
           <a:xfrm>
-            <a:off x="2423160" y="3694176"/>
+            <a:off x="2423160" y="3729344"/>
             <a:ext cx="1005840" cy="64008"/>
           </a:xfrm>
           <a:prstGeom prst="rect">
@@ -6388,7 +7228,7 @@
         </p:nvSpPr>
         <p:spPr>
           <a:xfrm>
-            <a:off x="2423160" y="3694176"/>
+            <a:off x="2423160" y="3729344"/>
             <a:ext cx="834847" cy="64008"/>
           </a:xfrm>
           <a:prstGeom prst="rect">
@@ -6498,7 +7338,7 @@
         </p:nvSpPr>
         <p:spPr>
           <a:xfrm>
-            <a:off x="4663440" y="3520440"/>
+            <a:off x="4663440" y="3538024"/>
             <a:ext cx="731520" cy="64008"/>
           </a:xfrm>
           <a:prstGeom prst="rect">
@@ -6530,7 +7370,7 @@
         </p:nvSpPr>
         <p:spPr>
           <a:xfrm>
-            <a:off x="4663440" y="3520440"/>
+            <a:off x="4663440" y="3538024"/>
             <a:ext cx="672998" cy="64008"/>
           </a:xfrm>
           <a:prstGeom prst="rect">
@@ -6828,7 +7668,7 @@
         </p:nvSpPr>
         <p:spPr>
           <a:xfrm>
-            <a:off x="2423160" y="4105656"/>
+            <a:off x="2423160" y="4140824"/>
             <a:ext cx="1005840" cy="64008"/>
           </a:xfrm>
           <a:prstGeom prst="rect">
@@ -6860,7 +7700,7 @@
         </p:nvSpPr>
         <p:spPr>
           <a:xfrm>
-            <a:off x="2423160" y="4105656"/>
+            <a:off x="2423160" y="4140824"/>
             <a:ext cx="945490" cy="64008"/>
           </a:xfrm>
           <a:prstGeom prst="rect">
@@ -6931,7 +7771,7 @@
         </p:nvSpPr>
         <p:spPr>
           <a:xfrm>
-            <a:off x="2423160" y="4379976"/>
+            <a:off x="2423160" y="4415144"/>
             <a:ext cx="1005840" cy="64008"/>
           </a:xfrm>
           <a:prstGeom prst="rect">
@@ -6963,7 +7803,7 @@
         </p:nvSpPr>
         <p:spPr>
           <a:xfrm>
-            <a:off x="2423160" y="4379976"/>
+            <a:off x="2423160" y="4415144"/>
             <a:ext cx="935431" cy="64008"/>
           </a:xfrm>
           <a:prstGeom prst="rect">
@@ -7073,7 +7913,7 @@
         </p:nvSpPr>
         <p:spPr>
           <a:xfrm>
-            <a:off x="4663440" y="4206240"/>
+            <a:off x="4663440" y="4223824"/>
             <a:ext cx="731520" cy="64008"/>
           </a:xfrm>
           <a:prstGeom prst="rect">
@@ -7105,7 +7945,7 @@
         </p:nvSpPr>
         <p:spPr>
           <a:xfrm>
-            <a:off x="4663440" y="4206240"/>
+            <a:off x="4663440" y="4223824"/>
             <a:ext cx="497434" cy="64008"/>
           </a:xfrm>
           <a:prstGeom prst="rect">
@@ -7467,13 +8307,15 @@
                 <a:solidFill>
                   <a:srgbClr val="8888AA"/>
                 </a:solidFill>
-                <a:latin typeface="Calibri" pitchFamily="34" charset="0"/>
+                <a:latin typeface="Consolas" panose="020B0609020204030204" pitchFamily="49" charset="0"/>
                 <a:ea typeface="Calibri" pitchFamily="34" charset="-122"/>
                 <a:cs typeface="Calibri" pitchFamily="34" charset="-120"/>
               </a:rPr>
               <a:t>Use DeepL for major market languages where native quality matters most. Fall back to Google for long-tail coverage. Route brand-critical campaign copy through Claude for nuanced output.</a:t>
             </a:r>
-            <a:endParaRPr lang="en-US" sz="1100" dirty="0"/>
+            <a:endParaRPr lang="en-US" sz="1100" dirty="0">
+              <a:latin typeface="Consolas" panose="020B0609020204030204" pitchFamily="49" charset="0"/>
+            </a:endParaRPr>
           </a:p>
         </p:txBody>
       </p:sp>
@@ -7701,7 +8543,7 @@
                 <a:ea typeface="Calibri" pitchFamily="34" charset="-122"/>
                 <a:cs typeface="Calibri" pitchFamily="34" charset="-120"/>
               </a:rPr>
-              <a:t>All product content, descriptions, UI — EU + JA + ZH</a:t>
+              <a:t>All product content, descriptions, DeepL supported Languages</a:t>
             </a:r>
             <a:endParaRPr lang="en-US" sz="900" dirty="0"/>
           </a:p>
@@ -8971,7 +9813,18 @@
                 <a:ea typeface="Calibri" pitchFamily="34" charset="-122"/>
                 <a:cs typeface="Calibri" pitchFamily="34" charset="-120"/>
               </a:rPr>
-              <a:t>Monthly Cost Estimate — Mid-Size Store</a:t>
+              <a:t>Monthly </a:t>
+            </a:r>
+            <a:r>
+              <a:rPr lang="en-US" sz="2600" b="1">
+                <a:solidFill>
+                  <a:srgbClr val="E8E8F0"/>
+                </a:solidFill>
+                <a:latin typeface="Calibri" pitchFamily="34" charset="0"/>
+                <a:ea typeface="Calibri" pitchFamily="34" charset="-122"/>
+                <a:cs typeface="Calibri" pitchFamily="34" charset="-120"/>
+              </a:rPr>
+              <a:t>Cost Estimate</a:t>
             </a:r>
             <a:endParaRPr lang="en-US" sz="2600" dirty="0"/>
           </a:p>
@@ -10830,43 +11683,13 @@
       </p:sp>
       <p:sp>
         <p:nvSpPr>
-          <p:cNvPr id="9" name="Shape 7"/>
-          <p:cNvSpPr/>
-          <p:nvPr/>
-        </p:nvSpPr>
-        <p:spPr>
-          <a:xfrm>
-            <a:off x="2240280" y="1709928"/>
-            <a:ext cx="0" cy="210312"/>
-          </a:xfrm>
-          <a:prstGeom prst="line">
-            <a:avLst/>
-          </a:prstGeom>
-          <a:noFill/>
-          <a:ln w="19050">
-            <a:solidFill>
-              <a:srgbClr val="FF6B35"/>
-            </a:solidFill>
-            <a:prstDash val="solid"/>
-          </a:ln>
-        </p:spPr>
-        <p:txBody>
-          <a:bodyPr/>
-          <a:lstStyle/>
-          <a:p>
-            <a:endParaRPr lang="en-US"/>
-          </a:p>
-        </p:txBody>
-      </p:sp>
-      <p:sp>
-        <p:nvSpPr>
           <p:cNvPr id="10" name="Shape 8"/>
           <p:cNvSpPr/>
           <p:nvPr/>
         </p:nvSpPr>
         <p:spPr>
           <a:xfrm>
-            <a:off x="365760" y="1920240"/>
+            <a:off x="4663440" y="914400"/>
             <a:ext cx="3749040" cy="749808"/>
           </a:xfrm>
           <a:prstGeom prst="rect">
@@ -10905,7 +11728,7 @@
         </p:nvSpPr>
         <p:spPr>
           <a:xfrm>
-            <a:off x="365760" y="1920240"/>
+            <a:off x="4663440" y="914400"/>
             <a:ext cx="54864" cy="749808"/>
           </a:xfrm>
           <a:prstGeom prst="rect">
@@ -10937,7 +11760,7 @@
         </p:nvSpPr>
         <p:spPr>
           <a:xfrm>
-            <a:off x="502920" y="1993392"/>
+            <a:off x="4800600" y="987552"/>
             <a:ext cx="365760" cy="228600"/>
           </a:xfrm>
           <a:prstGeom prst="rect">
@@ -10976,7 +11799,7 @@
         </p:nvSpPr>
         <p:spPr>
           <a:xfrm>
-            <a:off x="914400" y="1993392"/>
+            <a:off x="5212080" y="987552"/>
             <a:ext cx="3017520" cy="256032"/>
           </a:xfrm>
           <a:prstGeom prst="rect">
@@ -11015,7 +11838,7 @@
         </p:nvSpPr>
         <p:spPr>
           <a:xfrm>
-            <a:off x="914400" y="2267712"/>
+            <a:off x="5212080" y="1261872"/>
             <a:ext cx="3017520" cy="274320"/>
           </a:xfrm>
           <a:prstGeom prst="rect">
@@ -11048,25 +11871,598 @@
       </p:sp>
       <p:sp>
         <p:nvSpPr>
-          <p:cNvPr id="15" name="Shape 13"/>
-          <p:cNvSpPr/>
-          <p:nvPr/>
-        </p:nvSpPr>
-        <p:spPr>
-          <a:xfrm>
-            <a:off x="2240280" y="2670048"/>
-            <a:ext cx="0" cy="210312"/>
-          </a:xfrm>
-          <a:prstGeom prst="line">
-            <a:avLst/>
-          </a:prstGeom>
-          <a:noFill/>
-          <a:ln w="19050">
+          <p:cNvPr id="22" name="Shape 20"/>
+          <p:cNvSpPr/>
+          <p:nvPr/>
+        </p:nvSpPr>
+        <p:spPr>
+          <a:xfrm>
+            <a:off x="365760" y="1941695"/>
+            <a:ext cx="3749040" cy="749808"/>
+          </a:xfrm>
+          <a:prstGeom prst="rect">
+            <a:avLst/>
+          </a:prstGeom>
+          <a:solidFill>
+            <a:srgbClr val="0E0E20"/>
+          </a:solidFill>
+          <a:ln w="12700">
+            <a:solidFill>
+              <a:srgbClr val="E8E8F0"/>
+            </a:solidFill>
+            <a:prstDash val="solid"/>
+          </a:ln>
+          <a:effectLst>
+            <a:outerShdw blurRad="101600" dist="25400" dir="8100000" algn="bl" rotWithShape="0">
+              <a:srgbClr val="000000">
+                <a:alpha val="25000"/>
+              </a:srgbClr>
+            </a:outerShdw>
+          </a:effectLst>
+        </p:spPr>
+        <p:txBody>
+          <a:bodyPr/>
+          <a:lstStyle/>
+          <a:p>
+            <a:endParaRPr lang="en-US"/>
+          </a:p>
+        </p:txBody>
+      </p:sp>
+      <p:sp>
+        <p:nvSpPr>
+          <p:cNvPr id="23" name="Shape 21"/>
+          <p:cNvSpPr/>
+          <p:nvPr/>
+        </p:nvSpPr>
+        <p:spPr>
+          <a:xfrm>
+            <a:off x="365760" y="1941695"/>
+            <a:ext cx="54864" cy="749808"/>
+          </a:xfrm>
+          <a:prstGeom prst="rect">
+            <a:avLst/>
+          </a:prstGeom>
+          <a:solidFill>
+            <a:srgbClr val="E8E8F0"/>
+          </a:solidFill>
+          <a:ln w="12700">
+            <a:solidFill>
+              <a:srgbClr val="E8E8F0"/>
+            </a:solidFill>
+            <a:prstDash val="solid"/>
+          </a:ln>
+        </p:spPr>
+        <p:txBody>
+          <a:bodyPr/>
+          <a:lstStyle/>
+          <a:p>
+            <a:endParaRPr lang="en-US"/>
+          </a:p>
+        </p:txBody>
+      </p:sp>
+      <p:sp>
+        <p:nvSpPr>
+          <p:cNvPr id="24" name="Text 22"/>
+          <p:cNvSpPr/>
+          <p:nvPr/>
+        </p:nvSpPr>
+        <p:spPr>
+          <a:xfrm>
+            <a:off x="502920" y="2014847"/>
+            <a:ext cx="365760" cy="228600"/>
+          </a:xfrm>
+          <a:prstGeom prst="rect">
+            <a:avLst/>
+          </a:prstGeom>
+          <a:noFill/>
+          <a:ln/>
+        </p:spPr>
+        <p:txBody>
+          <a:bodyPr wrap="square" lIns="0" tIns="0" rIns="0" bIns="0" rtlCol="0" anchor="ctr"/>
+          <a:lstStyle/>
+          <a:p>
+            <a:pPr marL="0" indent="0">
+              <a:buNone/>
+            </a:pPr>
+            <a:r>
+              <a:rPr lang="en-US" sz="900" b="1" dirty="0">
+                <a:solidFill>
+                  <a:srgbClr val="E8E8F0"/>
+                </a:solidFill>
+                <a:latin typeface="Consolas" pitchFamily="34" charset="0"/>
+                <a:ea typeface="Consolas" pitchFamily="34" charset="-122"/>
+                <a:cs typeface="Consolas" pitchFamily="34" charset="-120"/>
+              </a:rPr>
+              <a:t>03</a:t>
+            </a:r>
+            <a:endParaRPr lang="en-US" sz="900" dirty="0"/>
+          </a:p>
+        </p:txBody>
+      </p:sp>
+      <p:sp>
+        <p:nvSpPr>
+          <p:cNvPr id="25" name="Text 23"/>
+          <p:cNvSpPr/>
+          <p:nvPr/>
+        </p:nvSpPr>
+        <p:spPr>
+          <a:xfrm>
+            <a:off x="914400" y="2014847"/>
+            <a:ext cx="3017520" cy="256032"/>
+          </a:xfrm>
+          <a:prstGeom prst="rect">
+            <a:avLst/>
+          </a:prstGeom>
+          <a:noFill/>
+          <a:ln/>
+        </p:spPr>
+        <p:txBody>
+          <a:bodyPr wrap="square" lIns="0" tIns="0" rIns="0" bIns="0" rtlCol="0" anchor="ctr"/>
+          <a:lstStyle/>
+          <a:p>
+            <a:pPr marL="0" indent="0">
+              <a:buNone/>
+            </a:pPr>
+            <a:r>
+              <a:rPr lang="en-US" sz="1100" b="1" dirty="0">
+                <a:solidFill>
+                  <a:srgbClr val="E8E8F0"/>
+                </a:solidFill>
+                <a:latin typeface="Calibri" pitchFamily="34" charset="0"/>
+                <a:ea typeface="Calibri" pitchFamily="34" charset="-122"/>
+                <a:cs typeface="Calibri" pitchFamily="34" charset="-120"/>
+              </a:rPr>
+              <a:t>Smart Router</a:t>
+            </a:r>
+            <a:endParaRPr lang="en-US" sz="1100" dirty="0"/>
+          </a:p>
+        </p:txBody>
+      </p:sp>
+      <p:sp>
+        <p:nvSpPr>
+          <p:cNvPr id="26" name="Text 24"/>
+          <p:cNvSpPr/>
+          <p:nvPr/>
+        </p:nvSpPr>
+        <p:spPr>
+          <a:xfrm>
+            <a:off x="914400" y="2289167"/>
+            <a:ext cx="3017520" cy="274320"/>
+          </a:xfrm>
+          <a:prstGeom prst="rect">
+            <a:avLst/>
+          </a:prstGeom>
+          <a:noFill/>
+          <a:ln/>
+        </p:spPr>
+        <p:txBody>
+          <a:bodyPr wrap="square" lIns="0" tIns="0" rIns="0" bIns="0" rtlCol="0" anchor="ctr"/>
+          <a:lstStyle/>
+          <a:p>
+            <a:pPr marL="0" indent="0">
+              <a:buNone/>
+            </a:pPr>
+            <a:r>
+              <a:rPr lang="en-US" sz="800" dirty="0">
+                <a:solidFill>
+                  <a:srgbClr val="8888AA"/>
+                </a:solidFill>
+                <a:latin typeface="Calibri" pitchFamily="34" charset="0"/>
+                <a:ea typeface="Calibri" pitchFamily="34" charset="-122"/>
+                <a:cs typeface="Calibri" pitchFamily="34" charset="-120"/>
+              </a:rPr>
+              <a:t>Content type · target language · cost budget</a:t>
+            </a:r>
+            <a:endParaRPr lang="en-US" sz="800" dirty="0"/>
+          </a:p>
+        </p:txBody>
+      </p:sp>
+      <p:sp>
+        <p:nvSpPr>
+          <p:cNvPr id="27" name="Shape 25"/>
+          <p:cNvSpPr/>
+          <p:nvPr/>
+        </p:nvSpPr>
+        <p:spPr>
+          <a:xfrm>
+            <a:off x="4663440" y="1924460"/>
+            <a:ext cx="3776466" cy="749808"/>
+          </a:xfrm>
+          <a:prstGeom prst="rect">
+            <a:avLst/>
+          </a:prstGeom>
+          <a:solidFill>
+            <a:srgbClr val="0E0E20"/>
+          </a:solidFill>
+          <a:ln w="12700">
+            <a:solidFill>
+              <a:srgbClr val="4285F4"/>
+            </a:solidFill>
+            <a:prstDash val="solid"/>
+          </a:ln>
+          <a:effectLst>
+            <a:outerShdw blurRad="101600" dist="25400" dir="8100000" algn="bl" rotWithShape="0">
+              <a:srgbClr val="000000">
+                <a:alpha val="25000"/>
+              </a:srgbClr>
+            </a:outerShdw>
+          </a:effectLst>
+        </p:spPr>
+        <p:txBody>
+          <a:bodyPr/>
+          <a:lstStyle/>
+          <a:p>
+            <a:endParaRPr lang="en-US"/>
+          </a:p>
+        </p:txBody>
+      </p:sp>
+      <p:sp>
+        <p:nvSpPr>
+          <p:cNvPr id="28" name="Shape 26"/>
+          <p:cNvSpPr/>
+          <p:nvPr/>
+        </p:nvSpPr>
+        <p:spPr>
+          <a:xfrm>
+            <a:off x="4663440" y="1924460"/>
+            <a:ext cx="54864" cy="749808"/>
+          </a:xfrm>
+          <a:prstGeom prst="rect">
+            <a:avLst/>
+          </a:prstGeom>
+          <a:solidFill>
+            <a:srgbClr val="4285F4"/>
+          </a:solidFill>
+          <a:ln w="12700">
+            <a:solidFill>
+              <a:srgbClr val="4285F4"/>
+            </a:solidFill>
+            <a:prstDash val="solid"/>
+          </a:ln>
+        </p:spPr>
+        <p:txBody>
+          <a:bodyPr/>
+          <a:lstStyle/>
+          <a:p>
+            <a:endParaRPr lang="en-US"/>
+          </a:p>
+        </p:txBody>
+      </p:sp>
+      <p:sp>
+        <p:nvSpPr>
+          <p:cNvPr id="29" name="Text 27"/>
+          <p:cNvSpPr/>
+          <p:nvPr/>
+        </p:nvSpPr>
+        <p:spPr>
+          <a:xfrm>
+            <a:off x="4800600" y="1997612"/>
+            <a:ext cx="365760" cy="228600"/>
+          </a:xfrm>
+          <a:prstGeom prst="rect">
+            <a:avLst/>
+          </a:prstGeom>
+          <a:noFill/>
+          <a:ln/>
+        </p:spPr>
+        <p:txBody>
+          <a:bodyPr wrap="square" lIns="0" tIns="0" rIns="0" bIns="0" rtlCol="0" anchor="ctr"/>
+          <a:lstStyle/>
+          <a:p>
+            <a:pPr marL="0" indent="0">
+              <a:buNone/>
+            </a:pPr>
+            <a:r>
+              <a:rPr lang="en-US" sz="900" b="1" dirty="0">
+                <a:solidFill>
+                  <a:srgbClr val="4285F4"/>
+                </a:solidFill>
+                <a:latin typeface="Consolas" pitchFamily="34" charset="0"/>
+                <a:ea typeface="Consolas" pitchFamily="34" charset="-122"/>
+                <a:cs typeface="Consolas" pitchFamily="34" charset="-120"/>
+              </a:rPr>
+              <a:t>04</a:t>
+            </a:r>
+            <a:endParaRPr lang="en-US" sz="900" dirty="0"/>
+          </a:p>
+        </p:txBody>
+      </p:sp>
+      <p:sp>
+        <p:nvSpPr>
+          <p:cNvPr id="30" name="Text 28"/>
+          <p:cNvSpPr/>
+          <p:nvPr/>
+        </p:nvSpPr>
+        <p:spPr>
+          <a:xfrm>
+            <a:off x="5212080" y="1997612"/>
+            <a:ext cx="3108960" cy="256032"/>
+          </a:xfrm>
+          <a:prstGeom prst="rect">
+            <a:avLst/>
+          </a:prstGeom>
+          <a:noFill/>
+          <a:ln/>
+        </p:spPr>
+        <p:txBody>
+          <a:bodyPr wrap="square" lIns="0" tIns="0" rIns="0" bIns="0" rtlCol="0" anchor="ctr"/>
+          <a:lstStyle/>
+          <a:p>
+            <a:pPr marL="0" indent="0">
+              <a:buNone/>
+            </a:pPr>
+            <a:r>
+              <a:rPr lang="en-US" sz="1100" b="1" dirty="0">
+                <a:solidFill>
+                  <a:srgbClr val="E8E8F0"/>
+                </a:solidFill>
+                <a:latin typeface="Calibri" pitchFamily="34" charset="0"/>
+                <a:ea typeface="Calibri" pitchFamily="34" charset="-122"/>
+                <a:cs typeface="Calibri" pitchFamily="34" charset="-120"/>
+              </a:rPr>
+              <a:t>Translation Engines</a:t>
+            </a:r>
+            <a:endParaRPr lang="en-US" sz="1100" dirty="0"/>
+          </a:p>
+        </p:txBody>
+      </p:sp>
+      <p:sp>
+        <p:nvSpPr>
+          <p:cNvPr id="31" name="Text 29"/>
+          <p:cNvSpPr/>
+          <p:nvPr/>
+        </p:nvSpPr>
+        <p:spPr>
+          <a:xfrm>
+            <a:off x="5212080" y="2271932"/>
+            <a:ext cx="3108960" cy="274320"/>
+          </a:xfrm>
+          <a:prstGeom prst="rect">
+            <a:avLst/>
+          </a:prstGeom>
+          <a:noFill/>
+          <a:ln/>
+        </p:spPr>
+        <p:txBody>
+          <a:bodyPr wrap="square" lIns="0" tIns="0" rIns="0" bIns="0" rtlCol="0" anchor="ctr"/>
+          <a:lstStyle/>
+          <a:p>
+            <a:pPr marL="0" indent="0">
+              <a:buNone/>
+            </a:pPr>
+            <a:r>
+              <a:rPr lang="en-US" sz="800" dirty="0">
+                <a:solidFill>
+                  <a:srgbClr val="8888AA"/>
+                </a:solidFill>
+                <a:latin typeface="Calibri" pitchFamily="34" charset="0"/>
+                <a:ea typeface="Calibri" pitchFamily="34" charset="-122"/>
+                <a:cs typeface="Calibri" pitchFamily="34" charset="-120"/>
+              </a:rPr>
+              <a:t>DeepL · Google · Claude (hybrid routing)</a:t>
+            </a:r>
+            <a:endParaRPr lang="en-US" sz="800" dirty="0"/>
+          </a:p>
+        </p:txBody>
+      </p:sp>
+      <p:sp>
+        <p:nvSpPr>
+          <p:cNvPr id="33" name="Shape 31"/>
+          <p:cNvSpPr/>
+          <p:nvPr/>
+        </p:nvSpPr>
+        <p:spPr>
+          <a:xfrm>
+            <a:off x="332348" y="2972503"/>
+            <a:ext cx="3782452" cy="749808"/>
+          </a:xfrm>
+          <a:prstGeom prst="rect">
+            <a:avLst/>
+          </a:prstGeom>
+          <a:solidFill>
+            <a:srgbClr val="0E0E20"/>
+          </a:solidFill>
+          <a:ln w="12700">
+            <a:solidFill>
+              <a:srgbClr val="9B59B6"/>
+            </a:solidFill>
+            <a:prstDash val="solid"/>
+          </a:ln>
+          <a:effectLst>
+            <a:outerShdw blurRad="101600" dist="25400" dir="8100000" algn="bl" rotWithShape="0">
+              <a:srgbClr val="000000">
+                <a:alpha val="25000"/>
+              </a:srgbClr>
+            </a:outerShdw>
+          </a:effectLst>
+        </p:spPr>
+        <p:txBody>
+          <a:bodyPr/>
+          <a:lstStyle/>
+          <a:p>
+            <a:endParaRPr lang="en-US"/>
+          </a:p>
+        </p:txBody>
+      </p:sp>
+      <p:sp>
+        <p:nvSpPr>
+          <p:cNvPr id="34" name="Shape 32"/>
+          <p:cNvSpPr/>
+          <p:nvPr/>
+        </p:nvSpPr>
+        <p:spPr>
+          <a:xfrm>
+            <a:off x="332348" y="2972503"/>
+            <a:ext cx="54864" cy="749808"/>
+          </a:xfrm>
+          <a:prstGeom prst="rect">
+            <a:avLst/>
+          </a:prstGeom>
+          <a:solidFill>
+            <a:srgbClr val="9B59B6"/>
+          </a:solidFill>
+          <a:ln w="12700">
+            <a:solidFill>
+              <a:srgbClr val="9B59B6"/>
+            </a:solidFill>
+            <a:prstDash val="solid"/>
+          </a:ln>
+        </p:spPr>
+        <p:txBody>
+          <a:bodyPr/>
+          <a:lstStyle/>
+          <a:p>
+            <a:endParaRPr lang="en-US"/>
+          </a:p>
+        </p:txBody>
+      </p:sp>
+      <p:sp>
+        <p:nvSpPr>
+          <p:cNvPr id="35" name="Text 33"/>
+          <p:cNvSpPr/>
+          <p:nvPr/>
+        </p:nvSpPr>
+        <p:spPr>
+          <a:xfrm>
+            <a:off x="469508" y="3045655"/>
+            <a:ext cx="365760" cy="228600"/>
+          </a:xfrm>
+          <a:prstGeom prst="rect">
+            <a:avLst/>
+          </a:prstGeom>
+          <a:noFill/>
+          <a:ln/>
+        </p:spPr>
+        <p:txBody>
+          <a:bodyPr wrap="square" lIns="0" tIns="0" rIns="0" bIns="0" rtlCol="0" anchor="ctr"/>
+          <a:lstStyle/>
+          <a:p>
+            <a:pPr marL="0" indent="0">
+              <a:buNone/>
+            </a:pPr>
+            <a:r>
+              <a:rPr lang="en-US" sz="900" b="1" dirty="0">
+                <a:solidFill>
+                  <a:srgbClr val="9B59B6"/>
+                </a:solidFill>
+                <a:latin typeface="Consolas" pitchFamily="34" charset="0"/>
+                <a:ea typeface="Consolas" pitchFamily="34" charset="-122"/>
+                <a:cs typeface="Consolas" pitchFamily="34" charset="-120"/>
+              </a:rPr>
+              <a:t>05</a:t>
+            </a:r>
+            <a:endParaRPr lang="en-US" sz="900" dirty="0"/>
+          </a:p>
+        </p:txBody>
+      </p:sp>
+      <p:sp>
+        <p:nvSpPr>
+          <p:cNvPr id="36" name="Text 34"/>
+          <p:cNvSpPr/>
+          <p:nvPr/>
+        </p:nvSpPr>
+        <p:spPr>
+          <a:xfrm>
+            <a:off x="880988" y="3045655"/>
+            <a:ext cx="3108960" cy="256032"/>
+          </a:xfrm>
+          <a:prstGeom prst="rect">
+            <a:avLst/>
+          </a:prstGeom>
+          <a:noFill/>
+          <a:ln/>
+        </p:spPr>
+        <p:txBody>
+          <a:bodyPr wrap="square" lIns="0" tIns="0" rIns="0" bIns="0" rtlCol="0" anchor="ctr"/>
+          <a:lstStyle/>
+          <a:p>
+            <a:pPr marL="0" indent="0">
+              <a:buNone/>
+            </a:pPr>
+            <a:r>
+              <a:rPr lang="en-US" sz="1100" b="1" dirty="0">
+                <a:solidFill>
+                  <a:srgbClr val="E8E8F0"/>
+                </a:solidFill>
+                <a:latin typeface="Calibri" pitchFamily="34" charset="0"/>
+                <a:ea typeface="Calibri" pitchFamily="34" charset="-122"/>
+                <a:cs typeface="Calibri" pitchFamily="34" charset="-120"/>
+              </a:rPr>
+              <a:t>Post-Processing</a:t>
+            </a:r>
+            <a:endParaRPr lang="en-US" sz="1100" dirty="0"/>
+          </a:p>
+        </p:txBody>
+      </p:sp>
+      <p:sp>
+        <p:nvSpPr>
+          <p:cNvPr id="37" name="Text 35"/>
+          <p:cNvSpPr/>
+          <p:nvPr/>
+        </p:nvSpPr>
+        <p:spPr>
+          <a:xfrm>
+            <a:off x="880988" y="3319975"/>
+            <a:ext cx="3108960" cy="274320"/>
+          </a:xfrm>
+          <a:prstGeom prst="rect">
+            <a:avLst/>
+          </a:prstGeom>
+          <a:noFill/>
+          <a:ln/>
+        </p:spPr>
+        <p:txBody>
+          <a:bodyPr wrap="square" lIns="0" tIns="0" rIns="0" bIns="0" rtlCol="0" anchor="ctr"/>
+          <a:lstStyle/>
+          <a:p>
+            <a:pPr marL="0" indent="0">
+              <a:buNone/>
+            </a:pPr>
+            <a:r>
+              <a:rPr lang="en-US" sz="800" dirty="0">
+                <a:solidFill>
+                  <a:srgbClr val="8888AA"/>
+                </a:solidFill>
+                <a:latin typeface="Calibri" pitchFamily="34" charset="0"/>
+                <a:ea typeface="Calibri" pitchFamily="34" charset="-122"/>
+                <a:cs typeface="Calibri" pitchFamily="34" charset="-120"/>
+              </a:rPr>
+              <a:t>Restore tags · quality score · store to TM</a:t>
+            </a:r>
+            <a:endParaRPr lang="en-US" sz="800" dirty="0"/>
+          </a:p>
+        </p:txBody>
+      </p:sp>
+      <p:sp>
+        <p:nvSpPr>
+          <p:cNvPr id="39" name="Shape 37"/>
+          <p:cNvSpPr/>
+          <p:nvPr/>
+        </p:nvSpPr>
+        <p:spPr>
+          <a:xfrm>
+            <a:off x="4653591" y="2972503"/>
+            <a:ext cx="3786315" cy="749808"/>
+          </a:xfrm>
+          <a:prstGeom prst="rect">
+            <a:avLst/>
+          </a:prstGeom>
+          <a:solidFill>
+            <a:srgbClr val="0E0E20"/>
+          </a:solidFill>
+          <a:ln w="12700">
             <a:solidFill>
               <a:srgbClr val="FFB800"/>
             </a:solidFill>
             <a:prstDash val="solid"/>
           </a:ln>
+          <a:effectLst>
+            <a:outerShdw blurRad="101600" dist="25400" dir="8100000" algn="bl" rotWithShape="0">
+              <a:srgbClr val="000000">
+                <a:alpha val="25000"/>
+              </a:srgbClr>
+            </a:outerShdw>
+          </a:effectLst>
         </p:spPr>
         <p:txBody>
           <a:bodyPr/>
@@ -11078,14 +12474,163 @@
       </p:sp>
       <p:sp>
         <p:nvSpPr>
-          <p:cNvPr id="16" name="Shape 14"/>
-          <p:cNvSpPr/>
-          <p:nvPr/>
-        </p:nvSpPr>
-        <p:spPr>
-          <a:xfrm>
-            <a:off x="365760" y="2880360"/>
-            <a:ext cx="3749040" cy="749808"/>
+          <p:cNvPr id="40" name="Shape 38"/>
+          <p:cNvSpPr/>
+          <p:nvPr/>
+        </p:nvSpPr>
+        <p:spPr>
+          <a:xfrm>
+            <a:off x="4653591" y="2972503"/>
+            <a:ext cx="54864" cy="749808"/>
+          </a:xfrm>
+          <a:prstGeom prst="rect">
+            <a:avLst/>
+          </a:prstGeom>
+          <a:solidFill>
+            <a:srgbClr val="FFB800"/>
+          </a:solidFill>
+          <a:ln w="12700">
+            <a:solidFill>
+              <a:srgbClr val="FFB800"/>
+            </a:solidFill>
+            <a:prstDash val="solid"/>
+          </a:ln>
+        </p:spPr>
+        <p:txBody>
+          <a:bodyPr/>
+          <a:lstStyle/>
+          <a:p>
+            <a:endParaRPr lang="en-US"/>
+          </a:p>
+        </p:txBody>
+      </p:sp>
+      <p:sp>
+        <p:nvSpPr>
+          <p:cNvPr id="41" name="Text 39"/>
+          <p:cNvSpPr/>
+          <p:nvPr/>
+        </p:nvSpPr>
+        <p:spPr>
+          <a:xfrm>
+            <a:off x="4790751" y="3045655"/>
+            <a:ext cx="365760" cy="228600"/>
+          </a:xfrm>
+          <a:prstGeom prst="rect">
+            <a:avLst/>
+          </a:prstGeom>
+          <a:noFill/>
+          <a:ln/>
+        </p:spPr>
+        <p:txBody>
+          <a:bodyPr wrap="square" lIns="0" tIns="0" rIns="0" bIns="0" rtlCol="0" anchor="ctr"/>
+          <a:lstStyle/>
+          <a:p>
+            <a:pPr marL="0" indent="0">
+              <a:buNone/>
+            </a:pPr>
+            <a:r>
+              <a:rPr lang="en-US" sz="900" b="1" dirty="0">
+                <a:solidFill>
+                  <a:srgbClr val="FFB800"/>
+                </a:solidFill>
+                <a:latin typeface="Consolas" pitchFamily="34" charset="0"/>
+                <a:ea typeface="Consolas" pitchFamily="34" charset="-122"/>
+                <a:cs typeface="Consolas" pitchFamily="34" charset="-120"/>
+              </a:rPr>
+              <a:t>06</a:t>
+            </a:r>
+            <a:endParaRPr lang="en-US" sz="900" dirty="0"/>
+          </a:p>
+        </p:txBody>
+      </p:sp>
+      <p:sp>
+        <p:nvSpPr>
+          <p:cNvPr id="42" name="Text 40"/>
+          <p:cNvSpPr/>
+          <p:nvPr/>
+        </p:nvSpPr>
+        <p:spPr>
+          <a:xfrm>
+            <a:off x="5202231" y="3045655"/>
+            <a:ext cx="3108960" cy="256032"/>
+          </a:xfrm>
+          <a:prstGeom prst="rect">
+            <a:avLst/>
+          </a:prstGeom>
+          <a:noFill/>
+          <a:ln/>
+        </p:spPr>
+        <p:txBody>
+          <a:bodyPr wrap="square" lIns="0" tIns="0" rIns="0" bIns="0" rtlCol="0" anchor="ctr"/>
+          <a:lstStyle/>
+          <a:p>
+            <a:pPr marL="0" indent="0">
+              <a:buNone/>
+            </a:pPr>
+            <a:r>
+              <a:rPr lang="en-US" sz="1100" b="1" dirty="0">
+                <a:solidFill>
+                  <a:srgbClr val="E8E8F0"/>
+                </a:solidFill>
+                <a:latin typeface="Calibri" pitchFamily="34" charset="0"/>
+                <a:ea typeface="Calibri" pitchFamily="34" charset="-122"/>
+                <a:cs typeface="Calibri" pitchFamily="34" charset="-120"/>
+              </a:rPr>
+              <a:t>Confidence Gate</a:t>
+            </a:r>
+            <a:endParaRPr lang="en-US" sz="1100" dirty="0"/>
+          </a:p>
+        </p:txBody>
+      </p:sp>
+      <p:sp>
+        <p:nvSpPr>
+          <p:cNvPr id="43" name="Text 41"/>
+          <p:cNvSpPr/>
+          <p:nvPr/>
+        </p:nvSpPr>
+        <p:spPr>
+          <a:xfrm>
+            <a:off x="5202231" y="3319975"/>
+            <a:ext cx="3108960" cy="274320"/>
+          </a:xfrm>
+          <a:prstGeom prst="rect">
+            <a:avLst/>
+          </a:prstGeom>
+          <a:noFill/>
+          <a:ln/>
+        </p:spPr>
+        <p:txBody>
+          <a:bodyPr wrap="square" lIns="0" tIns="0" rIns="0" bIns="0" rtlCol="0" anchor="ctr"/>
+          <a:lstStyle/>
+          <a:p>
+            <a:pPr marL="0" indent="0">
+              <a:buNone/>
+            </a:pPr>
+            <a:r>
+              <a:rPr lang="en-US" sz="800" dirty="0">
+                <a:solidFill>
+                  <a:srgbClr val="8888AA"/>
+                </a:solidFill>
+                <a:latin typeface="Calibri" pitchFamily="34" charset="0"/>
+                <a:ea typeface="Calibri" pitchFamily="34" charset="-122"/>
+                <a:cs typeface="Calibri" pitchFamily="34" charset="-120"/>
+              </a:rPr>
+              <a:t>&gt;95% auto-publish · 80-95% review · &lt;80% block</a:t>
+            </a:r>
+            <a:endParaRPr lang="en-US" sz="800" dirty="0"/>
+          </a:p>
+        </p:txBody>
+      </p:sp>
+      <p:sp>
+        <p:nvSpPr>
+          <p:cNvPr id="46" name="Shape 44"/>
+          <p:cNvSpPr/>
+          <p:nvPr/>
+        </p:nvSpPr>
+        <p:spPr>
+          <a:xfrm>
+            <a:off x="1463040" y="4435895"/>
+            <a:ext cx="2286000" cy="548640"/>
           </a:xfrm>
           <a:prstGeom prst="rect">
             <a:avLst/>
@@ -11117,14 +12662,14 @@
       </p:sp>
       <p:sp>
         <p:nvSpPr>
-          <p:cNvPr id="17" name="Shape 15"/>
-          <p:cNvSpPr/>
-          <p:nvPr/>
-        </p:nvSpPr>
-        <p:spPr>
-          <a:xfrm>
-            <a:off x="365760" y="2880360"/>
-            <a:ext cx="54864" cy="749808"/>
+          <p:cNvPr id="47" name="Shape 45"/>
+          <p:cNvSpPr/>
+          <p:nvPr/>
+        </p:nvSpPr>
+        <p:spPr>
+          <a:xfrm>
+            <a:off x="1463040" y="4435895"/>
+            <a:ext cx="54864" cy="548640"/>
           </a:xfrm>
           <a:prstGeom prst="rect">
             <a:avLst/>
@@ -11149,77 +12694,38 @@
       </p:sp>
       <p:sp>
         <p:nvSpPr>
-          <p:cNvPr id="18" name="Text 16"/>
-          <p:cNvSpPr/>
-          <p:nvPr/>
-        </p:nvSpPr>
-        <p:spPr>
-          <a:xfrm>
-            <a:off x="502920" y="2953512"/>
-            <a:ext cx="365760" cy="228600"/>
-          </a:xfrm>
-          <a:prstGeom prst="rect">
-            <a:avLst/>
-          </a:prstGeom>
-          <a:noFill/>
-          <a:ln/>
-        </p:spPr>
-        <p:txBody>
-          <a:bodyPr wrap="square" lIns="0" tIns="0" rIns="0" bIns="0" rtlCol="0" anchor="ctr"/>
-          <a:lstStyle/>
-          <a:p>
-            <a:pPr marL="0" indent="0">
-              <a:buNone/>
-            </a:pPr>
-            <a:r>
-              <a:rPr lang="en-US" sz="900" b="1" dirty="0">
+          <p:cNvPr id="48" name="Text 46"/>
+          <p:cNvSpPr/>
+          <p:nvPr/>
+        </p:nvSpPr>
+        <p:spPr>
+          <a:xfrm>
+            <a:off x="1609344" y="4509047"/>
+            <a:ext cx="2057400" cy="219456"/>
+          </a:xfrm>
+          <a:prstGeom prst="rect">
+            <a:avLst/>
+          </a:prstGeom>
+          <a:noFill/>
+          <a:ln/>
+        </p:spPr>
+        <p:txBody>
+          <a:bodyPr wrap="square" lIns="0" tIns="0" rIns="0" bIns="0" rtlCol="0" anchor="ctr"/>
+          <a:lstStyle/>
+          <a:p>
+            <a:pPr marL="0" indent="0">
+              <a:buNone/>
+            </a:pPr>
+            <a:r>
+              <a:rPr lang="en-US" sz="1100" b="1" dirty="0">
                 <a:solidFill>
                   <a:srgbClr val="00D4A0"/>
-                </a:solidFill>
-                <a:latin typeface="Consolas" pitchFamily="34" charset="0"/>
-                <a:ea typeface="Consolas" pitchFamily="34" charset="-122"/>
-                <a:cs typeface="Consolas" pitchFamily="34" charset="-120"/>
-              </a:rPr>
-              <a:t>03</a:t>
-            </a:r>
-            <a:endParaRPr lang="en-US" sz="900" dirty="0"/>
-          </a:p>
-        </p:txBody>
-      </p:sp>
-      <p:sp>
-        <p:nvSpPr>
-          <p:cNvPr id="19" name="Text 17"/>
-          <p:cNvSpPr/>
-          <p:nvPr/>
-        </p:nvSpPr>
-        <p:spPr>
-          <a:xfrm>
-            <a:off x="914400" y="2953512"/>
-            <a:ext cx="3017520" cy="256032"/>
-          </a:xfrm>
-          <a:prstGeom prst="rect">
-            <a:avLst/>
-          </a:prstGeom>
-          <a:noFill/>
-          <a:ln/>
-        </p:spPr>
-        <p:txBody>
-          <a:bodyPr wrap="square" lIns="0" tIns="0" rIns="0" bIns="0" rtlCol="0" anchor="ctr"/>
-          <a:lstStyle/>
-          <a:p>
-            <a:pPr marL="0" indent="0">
-              <a:buNone/>
-            </a:pPr>
-            <a:r>
-              <a:rPr lang="en-US" sz="1100" b="1" dirty="0">
-                <a:solidFill>
-                  <a:srgbClr val="E8E8F0"/>
                 </a:solidFill>
                 <a:latin typeface="Calibri" pitchFamily="34" charset="0"/>
                 <a:ea typeface="Calibri" pitchFamily="34" charset="-122"/>
                 <a:cs typeface="Calibri" pitchFamily="34" charset="-120"/>
               </a:rPr>
-              <a:t>TM Cache Check</a:t>
+              <a:t>Auto Publish</a:t>
             </a:r>
             <a:endParaRPr lang="en-US" sz="1100" dirty="0"/>
           </a:p>
@@ -11227,30 +12733,30 @@
       </p:sp>
       <p:sp>
         <p:nvSpPr>
-          <p:cNvPr id="20" name="Text 18"/>
-          <p:cNvSpPr/>
-          <p:nvPr/>
-        </p:nvSpPr>
-        <p:spPr>
-          <a:xfrm>
-            <a:off x="914400" y="3227832"/>
-            <a:ext cx="3017520" cy="274320"/>
-          </a:xfrm>
-          <a:prstGeom prst="rect">
-            <a:avLst/>
-          </a:prstGeom>
-          <a:noFill/>
-          <a:ln/>
-        </p:spPr>
-        <p:txBody>
-          <a:bodyPr wrap="square" lIns="0" tIns="0" rIns="0" bIns="0" rtlCol="0" anchor="ctr"/>
-          <a:lstStyle/>
-          <a:p>
-            <a:pPr marL="0" indent="0">
-              <a:buNone/>
-            </a:pPr>
-            <a:r>
-              <a:rPr lang="en-US" sz="800" dirty="0">
+          <p:cNvPr id="49" name="Text 47"/>
+          <p:cNvSpPr/>
+          <p:nvPr/>
+        </p:nvSpPr>
+        <p:spPr>
+          <a:xfrm>
+            <a:off x="1572768" y="4728503"/>
+            <a:ext cx="2057400" cy="182880"/>
+          </a:xfrm>
+          <a:prstGeom prst="rect">
+            <a:avLst/>
+          </a:prstGeom>
+          <a:noFill/>
+          <a:ln/>
+        </p:spPr>
+        <p:txBody>
+          <a:bodyPr wrap="square" lIns="0" tIns="0" rIns="0" bIns="0" rtlCol="0" anchor="ctr"/>
+          <a:lstStyle/>
+          <a:p>
+            <a:pPr marL="0" indent="0">
+              <a:buNone/>
+            </a:pPr>
+            <a:r>
+              <a:rPr lang="en-US" sz="900" dirty="0">
                 <a:solidFill>
                   <a:srgbClr val="8888AA"/>
                 </a:solidFill>
@@ -11258,147 +12764,7 @@
                 <a:ea typeface="Calibri" pitchFamily="34" charset="-122"/>
                 <a:cs typeface="Calibri" pitchFamily="34" charset="-120"/>
               </a:rPr>
-              <a:t>Redis lookup · 100% hit = $0 API call</a:t>
-            </a:r>
-            <a:endParaRPr lang="en-US" sz="800" dirty="0"/>
-          </a:p>
-        </p:txBody>
-      </p:sp>
-      <p:sp>
-        <p:nvSpPr>
-          <p:cNvPr id="21" name="Shape 19"/>
-          <p:cNvSpPr/>
-          <p:nvPr/>
-        </p:nvSpPr>
-        <p:spPr>
-          <a:xfrm>
-            <a:off x="2240280" y="3630168"/>
-            <a:ext cx="0" cy="210312"/>
-          </a:xfrm>
-          <a:prstGeom prst="line">
-            <a:avLst/>
-          </a:prstGeom>
-          <a:noFill/>
-          <a:ln w="19050">
-            <a:solidFill>
-              <a:srgbClr val="00D4A0"/>
-            </a:solidFill>
-            <a:prstDash val="solid"/>
-          </a:ln>
-        </p:spPr>
-        <p:txBody>
-          <a:bodyPr/>
-          <a:lstStyle/>
-          <a:p>
-            <a:endParaRPr lang="en-US"/>
-          </a:p>
-        </p:txBody>
-      </p:sp>
-      <p:sp>
-        <p:nvSpPr>
-          <p:cNvPr id="22" name="Shape 20"/>
-          <p:cNvSpPr/>
-          <p:nvPr/>
-        </p:nvSpPr>
-        <p:spPr>
-          <a:xfrm>
-            <a:off x="365760" y="3840480"/>
-            <a:ext cx="3749040" cy="749808"/>
-          </a:xfrm>
-          <a:prstGeom prst="rect">
-            <a:avLst/>
-          </a:prstGeom>
-          <a:solidFill>
-            <a:srgbClr val="0E0E20"/>
-          </a:solidFill>
-          <a:ln w="12700">
-            <a:solidFill>
-              <a:srgbClr val="E8E8F0"/>
-            </a:solidFill>
-            <a:prstDash val="solid"/>
-          </a:ln>
-          <a:effectLst>
-            <a:outerShdw blurRad="101600" dist="25400" dir="8100000" algn="bl" rotWithShape="0">
-              <a:srgbClr val="000000">
-                <a:alpha val="25000"/>
-              </a:srgbClr>
-            </a:outerShdw>
-          </a:effectLst>
-        </p:spPr>
-        <p:txBody>
-          <a:bodyPr/>
-          <a:lstStyle/>
-          <a:p>
-            <a:endParaRPr lang="en-US"/>
-          </a:p>
-        </p:txBody>
-      </p:sp>
-      <p:sp>
-        <p:nvSpPr>
-          <p:cNvPr id="23" name="Shape 21"/>
-          <p:cNvSpPr/>
-          <p:nvPr/>
-        </p:nvSpPr>
-        <p:spPr>
-          <a:xfrm>
-            <a:off x="365760" y="3840480"/>
-            <a:ext cx="54864" cy="749808"/>
-          </a:xfrm>
-          <a:prstGeom prst="rect">
-            <a:avLst/>
-          </a:prstGeom>
-          <a:solidFill>
-            <a:srgbClr val="E8E8F0"/>
-          </a:solidFill>
-          <a:ln w="12700">
-            <a:solidFill>
-              <a:srgbClr val="E8E8F0"/>
-            </a:solidFill>
-            <a:prstDash val="solid"/>
-          </a:ln>
-        </p:spPr>
-        <p:txBody>
-          <a:bodyPr/>
-          <a:lstStyle/>
-          <a:p>
-            <a:endParaRPr lang="en-US"/>
-          </a:p>
-        </p:txBody>
-      </p:sp>
-      <p:sp>
-        <p:nvSpPr>
-          <p:cNvPr id="24" name="Text 22"/>
-          <p:cNvSpPr/>
-          <p:nvPr/>
-        </p:nvSpPr>
-        <p:spPr>
-          <a:xfrm>
-            <a:off x="502920" y="3913632"/>
-            <a:ext cx="365760" cy="228600"/>
-          </a:xfrm>
-          <a:prstGeom prst="rect">
-            <a:avLst/>
-          </a:prstGeom>
-          <a:noFill/>
-          <a:ln/>
-        </p:spPr>
-        <p:txBody>
-          <a:bodyPr wrap="square" lIns="0" tIns="0" rIns="0" bIns="0" rtlCol="0" anchor="ctr"/>
-          <a:lstStyle/>
-          <a:p>
-            <a:pPr marL="0" indent="0">
-              <a:buNone/>
-            </a:pPr>
-            <a:r>
-              <a:rPr lang="en-US" sz="900" b="1" dirty="0">
-                <a:solidFill>
-                  <a:srgbClr val="E8E8F0"/>
-                </a:solidFill>
-                <a:latin typeface="Consolas" pitchFamily="34" charset="0"/>
-                <a:ea typeface="Consolas" pitchFamily="34" charset="-122"/>
-                <a:cs typeface="Consolas" pitchFamily="34" charset="-120"/>
-              </a:rPr>
-              <a:t>04</a:t>
+              <a:t>Storefront CDN</a:t>
             </a:r>
             <a:endParaRPr lang="en-US" sz="900" dirty="0"/>
           </a:p>
@@ -11406,528 +12772,14 @@
       </p:sp>
       <p:sp>
         <p:nvSpPr>
-          <p:cNvPr id="25" name="Text 23"/>
-          <p:cNvSpPr/>
-          <p:nvPr/>
-        </p:nvSpPr>
-        <p:spPr>
-          <a:xfrm>
-            <a:off x="914400" y="3913632"/>
-            <a:ext cx="3017520" cy="256032"/>
-          </a:xfrm>
-          <a:prstGeom prst="rect">
-            <a:avLst/>
-          </a:prstGeom>
-          <a:noFill/>
-          <a:ln/>
-        </p:spPr>
-        <p:txBody>
-          <a:bodyPr wrap="square" lIns="0" tIns="0" rIns="0" bIns="0" rtlCol="0" anchor="ctr"/>
-          <a:lstStyle/>
-          <a:p>
-            <a:pPr marL="0" indent="0">
-              <a:buNone/>
-            </a:pPr>
-            <a:r>
-              <a:rPr lang="en-US" sz="1100" b="1" dirty="0">
-                <a:solidFill>
-                  <a:srgbClr val="E8E8F0"/>
-                </a:solidFill>
-                <a:latin typeface="Calibri" pitchFamily="34" charset="0"/>
-                <a:ea typeface="Calibri" pitchFamily="34" charset="-122"/>
-                <a:cs typeface="Calibri" pitchFamily="34" charset="-120"/>
-              </a:rPr>
-              <a:t>Smart Router</a:t>
-            </a:r>
-            <a:endParaRPr lang="en-US" sz="1100" dirty="0"/>
-          </a:p>
-        </p:txBody>
-      </p:sp>
-      <p:sp>
-        <p:nvSpPr>
-          <p:cNvPr id="26" name="Text 24"/>
-          <p:cNvSpPr/>
-          <p:nvPr/>
-        </p:nvSpPr>
-        <p:spPr>
-          <a:xfrm>
-            <a:off x="914400" y="4187952"/>
-            <a:ext cx="3017520" cy="274320"/>
-          </a:xfrm>
-          <a:prstGeom prst="rect">
-            <a:avLst/>
-          </a:prstGeom>
-          <a:noFill/>
-          <a:ln/>
-        </p:spPr>
-        <p:txBody>
-          <a:bodyPr wrap="square" lIns="0" tIns="0" rIns="0" bIns="0" rtlCol="0" anchor="ctr"/>
-          <a:lstStyle/>
-          <a:p>
-            <a:pPr marL="0" indent="0">
-              <a:buNone/>
-            </a:pPr>
-            <a:r>
-              <a:rPr lang="en-US" sz="800" dirty="0">
-                <a:solidFill>
-                  <a:srgbClr val="8888AA"/>
-                </a:solidFill>
-                <a:latin typeface="Calibri" pitchFamily="34" charset="0"/>
-                <a:ea typeface="Calibri" pitchFamily="34" charset="-122"/>
-                <a:cs typeface="Calibri" pitchFamily="34" charset="-120"/>
-              </a:rPr>
-              <a:t>Content type · target language · cost budget</a:t>
-            </a:r>
-            <a:endParaRPr lang="en-US" sz="800" dirty="0"/>
-          </a:p>
-        </p:txBody>
-      </p:sp>
-      <p:sp>
-        <p:nvSpPr>
-          <p:cNvPr id="27" name="Shape 25"/>
-          <p:cNvSpPr/>
-          <p:nvPr/>
-        </p:nvSpPr>
-        <p:spPr>
-          <a:xfrm>
-            <a:off x="4892040" y="960120"/>
-            <a:ext cx="3886200" cy="749808"/>
-          </a:xfrm>
-          <a:prstGeom prst="rect">
-            <a:avLst/>
-          </a:prstGeom>
-          <a:solidFill>
-            <a:srgbClr val="0E0E20"/>
-          </a:solidFill>
-          <a:ln w="12700">
-            <a:solidFill>
-              <a:srgbClr val="4285F4"/>
-            </a:solidFill>
-            <a:prstDash val="solid"/>
-          </a:ln>
-          <a:effectLst>
-            <a:outerShdw blurRad="101600" dist="25400" dir="8100000" algn="bl" rotWithShape="0">
-              <a:srgbClr val="000000">
-                <a:alpha val="25000"/>
-              </a:srgbClr>
-            </a:outerShdw>
-          </a:effectLst>
-        </p:spPr>
-        <p:txBody>
-          <a:bodyPr/>
-          <a:lstStyle/>
-          <a:p>
-            <a:endParaRPr lang="en-US"/>
-          </a:p>
-        </p:txBody>
-      </p:sp>
-      <p:sp>
-        <p:nvSpPr>
-          <p:cNvPr id="28" name="Shape 26"/>
-          <p:cNvSpPr/>
-          <p:nvPr/>
-        </p:nvSpPr>
-        <p:spPr>
-          <a:xfrm>
-            <a:off x="4892040" y="960120"/>
-            <a:ext cx="54864" cy="749808"/>
-          </a:xfrm>
-          <a:prstGeom prst="rect">
-            <a:avLst/>
-          </a:prstGeom>
-          <a:solidFill>
-            <a:srgbClr val="4285F4"/>
-          </a:solidFill>
-          <a:ln w="12700">
-            <a:solidFill>
-              <a:srgbClr val="4285F4"/>
-            </a:solidFill>
-            <a:prstDash val="solid"/>
-          </a:ln>
-        </p:spPr>
-        <p:txBody>
-          <a:bodyPr/>
-          <a:lstStyle/>
-          <a:p>
-            <a:endParaRPr lang="en-US"/>
-          </a:p>
-        </p:txBody>
-      </p:sp>
-      <p:sp>
-        <p:nvSpPr>
-          <p:cNvPr id="29" name="Text 27"/>
-          <p:cNvSpPr/>
-          <p:nvPr/>
-        </p:nvSpPr>
-        <p:spPr>
-          <a:xfrm>
-            <a:off x="5029200" y="1033272"/>
-            <a:ext cx="365760" cy="228600"/>
-          </a:xfrm>
-          <a:prstGeom prst="rect">
-            <a:avLst/>
-          </a:prstGeom>
-          <a:noFill/>
-          <a:ln/>
-        </p:spPr>
-        <p:txBody>
-          <a:bodyPr wrap="square" lIns="0" tIns="0" rIns="0" bIns="0" rtlCol="0" anchor="ctr"/>
-          <a:lstStyle/>
-          <a:p>
-            <a:pPr marL="0" indent="0">
-              <a:buNone/>
-            </a:pPr>
-            <a:r>
-              <a:rPr lang="en-US" sz="900" b="1" dirty="0">
-                <a:solidFill>
-                  <a:srgbClr val="4285F4"/>
-                </a:solidFill>
-                <a:latin typeface="Consolas" pitchFamily="34" charset="0"/>
-                <a:ea typeface="Consolas" pitchFamily="34" charset="-122"/>
-                <a:cs typeface="Consolas" pitchFamily="34" charset="-120"/>
-              </a:rPr>
-              <a:t>05</a:t>
-            </a:r>
-            <a:endParaRPr lang="en-US" sz="900" dirty="0"/>
-          </a:p>
-        </p:txBody>
-      </p:sp>
-      <p:sp>
-        <p:nvSpPr>
-          <p:cNvPr id="30" name="Text 28"/>
-          <p:cNvSpPr/>
-          <p:nvPr/>
-        </p:nvSpPr>
-        <p:spPr>
-          <a:xfrm>
-            <a:off x="5440680" y="1033272"/>
-            <a:ext cx="3108960" cy="256032"/>
-          </a:xfrm>
-          <a:prstGeom prst="rect">
-            <a:avLst/>
-          </a:prstGeom>
-          <a:noFill/>
-          <a:ln/>
-        </p:spPr>
-        <p:txBody>
-          <a:bodyPr wrap="square" lIns="0" tIns="0" rIns="0" bIns="0" rtlCol="0" anchor="ctr"/>
-          <a:lstStyle/>
-          <a:p>
-            <a:pPr marL="0" indent="0">
-              <a:buNone/>
-            </a:pPr>
-            <a:r>
-              <a:rPr lang="en-US" sz="1100" b="1" dirty="0">
-                <a:solidFill>
-                  <a:srgbClr val="E8E8F0"/>
-                </a:solidFill>
-                <a:latin typeface="Calibri" pitchFamily="34" charset="0"/>
-                <a:ea typeface="Calibri" pitchFamily="34" charset="-122"/>
-                <a:cs typeface="Calibri" pitchFamily="34" charset="-120"/>
-              </a:rPr>
-              <a:t>Translation Engines</a:t>
-            </a:r>
-            <a:endParaRPr lang="en-US" sz="1100" dirty="0"/>
-          </a:p>
-        </p:txBody>
-      </p:sp>
-      <p:sp>
-        <p:nvSpPr>
-          <p:cNvPr id="31" name="Text 29"/>
-          <p:cNvSpPr/>
-          <p:nvPr/>
-        </p:nvSpPr>
-        <p:spPr>
-          <a:xfrm>
-            <a:off x="5440680" y="1307592"/>
-            <a:ext cx="3108960" cy="274320"/>
-          </a:xfrm>
-          <a:prstGeom prst="rect">
-            <a:avLst/>
-          </a:prstGeom>
-          <a:noFill/>
-          <a:ln/>
-        </p:spPr>
-        <p:txBody>
-          <a:bodyPr wrap="square" lIns="0" tIns="0" rIns="0" bIns="0" rtlCol="0" anchor="ctr"/>
-          <a:lstStyle/>
-          <a:p>
-            <a:pPr marL="0" indent="0">
-              <a:buNone/>
-            </a:pPr>
-            <a:r>
-              <a:rPr lang="en-US" sz="800" dirty="0">
-                <a:solidFill>
-                  <a:srgbClr val="8888AA"/>
-                </a:solidFill>
-                <a:latin typeface="Calibri" pitchFamily="34" charset="0"/>
-                <a:ea typeface="Calibri" pitchFamily="34" charset="-122"/>
-                <a:cs typeface="Calibri" pitchFamily="34" charset="-120"/>
-              </a:rPr>
-              <a:t>DeepL · Google · Claude (hybrid routing)</a:t>
-            </a:r>
-            <a:endParaRPr lang="en-US" sz="800" dirty="0"/>
-          </a:p>
-        </p:txBody>
-      </p:sp>
-      <p:sp>
-        <p:nvSpPr>
-          <p:cNvPr id="32" name="Shape 30"/>
-          <p:cNvSpPr/>
-          <p:nvPr/>
-        </p:nvSpPr>
-        <p:spPr>
-          <a:xfrm>
-            <a:off x="6839712" y="1709928"/>
-            <a:ext cx="0" cy="210312"/>
-          </a:xfrm>
-          <a:prstGeom prst="line">
-            <a:avLst/>
-          </a:prstGeom>
-          <a:noFill/>
-          <a:ln w="19050">
-            <a:solidFill>
-              <a:srgbClr val="4285F4"/>
-            </a:solidFill>
-            <a:prstDash val="solid"/>
-          </a:ln>
-        </p:spPr>
-        <p:txBody>
-          <a:bodyPr/>
-          <a:lstStyle/>
-          <a:p>
-            <a:endParaRPr lang="en-US"/>
-          </a:p>
-        </p:txBody>
-      </p:sp>
-      <p:sp>
-        <p:nvSpPr>
-          <p:cNvPr id="33" name="Shape 31"/>
-          <p:cNvSpPr/>
-          <p:nvPr/>
-        </p:nvSpPr>
-        <p:spPr>
-          <a:xfrm>
-            <a:off x="4892040" y="1920240"/>
-            <a:ext cx="3886200" cy="749808"/>
-          </a:xfrm>
-          <a:prstGeom prst="rect">
-            <a:avLst/>
-          </a:prstGeom>
-          <a:solidFill>
-            <a:srgbClr val="0E0E20"/>
-          </a:solidFill>
-          <a:ln w="12700">
-            <a:solidFill>
-              <a:srgbClr val="9B59B6"/>
-            </a:solidFill>
-            <a:prstDash val="solid"/>
-          </a:ln>
-          <a:effectLst>
-            <a:outerShdw blurRad="101600" dist="25400" dir="8100000" algn="bl" rotWithShape="0">
-              <a:srgbClr val="000000">
-                <a:alpha val="25000"/>
-              </a:srgbClr>
-            </a:outerShdw>
-          </a:effectLst>
-        </p:spPr>
-        <p:txBody>
-          <a:bodyPr/>
-          <a:lstStyle/>
-          <a:p>
-            <a:endParaRPr lang="en-US"/>
-          </a:p>
-        </p:txBody>
-      </p:sp>
-      <p:sp>
-        <p:nvSpPr>
-          <p:cNvPr id="34" name="Shape 32"/>
-          <p:cNvSpPr/>
-          <p:nvPr/>
-        </p:nvSpPr>
-        <p:spPr>
-          <a:xfrm>
-            <a:off x="4892040" y="1920240"/>
-            <a:ext cx="54864" cy="749808"/>
-          </a:xfrm>
-          <a:prstGeom prst="rect">
-            <a:avLst/>
-          </a:prstGeom>
-          <a:solidFill>
-            <a:srgbClr val="9B59B6"/>
-          </a:solidFill>
-          <a:ln w="12700">
-            <a:solidFill>
-              <a:srgbClr val="9B59B6"/>
-            </a:solidFill>
-            <a:prstDash val="solid"/>
-          </a:ln>
-        </p:spPr>
-        <p:txBody>
-          <a:bodyPr/>
-          <a:lstStyle/>
-          <a:p>
-            <a:endParaRPr lang="en-US"/>
-          </a:p>
-        </p:txBody>
-      </p:sp>
-      <p:sp>
-        <p:nvSpPr>
-          <p:cNvPr id="35" name="Text 33"/>
-          <p:cNvSpPr/>
-          <p:nvPr/>
-        </p:nvSpPr>
-        <p:spPr>
-          <a:xfrm>
-            <a:off x="5029200" y="1993392"/>
-            <a:ext cx="365760" cy="228600"/>
-          </a:xfrm>
-          <a:prstGeom prst="rect">
-            <a:avLst/>
-          </a:prstGeom>
-          <a:noFill/>
-          <a:ln/>
-        </p:spPr>
-        <p:txBody>
-          <a:bodyPr wrap="square" lIns="0" tIns="0" rIns="0" bIns="0" rtlCol="0" anchor="ctr"/>
-          <a:lstStyle/>
-          <a:p>
-            <a:pPr marL="0" indent="0">
-              <a:buNone/>
-            </a:pPr>
-            <a:r>
-              <a:rPr lang="en-US" sz="900" b="1" dirty="0">
-                <a:solidFill>
-                  <a:srgbClr val="9B59B6"/>
-                </a:solidFill>
-                <a:latin typeface="Consolas" pitchFamily="34" charset="0"/>
-                <a:ea typeface="Consolas" pitchFamily="34" charset="-122"/>
-                <a:cs typeface="Consolas" pitchFamily="34" charset="-120"/>
-              </a:rPr>
-              <a:t>06</a:t>
-            </a:r>
-            <a:endParaRPr lang="en-US" sz="900" dirty="0"/>
-          </a:p>
-        </p:txBody>
-      </p:sp>
-      <p:sp>
-        <p:nvSpPr>
-          <p:cNvPr id="36" name="Text 34"/>
-          <p:cNvSpPr/>
-          <p:nvPr/>
-        </p:nvSpPr>
-        <p:spPr>
-          <a:xfrm>
-            <a:off x="5440680" y="1993392"/>
-            <a:ext cx="3108960" cy="256032"/>
-          </a:xfrm>
-          <a:prstGeom prst="rect">
-            <a:avLst/>
-          </a:prstGeom>
-          <a:noFill/>
-          <a:ln/>
-        </p:spPr>
-        <p:txBody>
-          <a:bodyPr wrap="square" lIns="0" tIns="0" rIns="0" bIns="0" rtlCol="0" anchor="ctr"/>
-          <a:lstStyle/>
-          <a:p>
-            <a:pPr marL="0" indent="0">
-              <a:buNone/>
-            </a:pPr>
-            <a:r>
-              <a:rPr lang="en-US" sz="1100" b="1" dirty="0">
-                <a:solidFill>
-                  <a:srgbClr val="E8E8F0"/>
-                </a:solidFill>
-                <a:latin typeface="Calibri" pitchFamily="34" charset="0"/>
-                <a:ea typeface="Calibri" pitchFamily="34" charset="-122"/>
-                <a:cs typeface="Calibri" pitchFamily="34" charset="-120"/>
-              </a:rPr>
-              <a:t>Post-Processing</a:t>
-            </a:r>
-            <a:endParaRPr lang="en-US" sz="1100" dirty="0"/>
-          </a:p>
-        </p:txBody>
-      </p:sp>
-      <p:sp>
-        <p:nvSpPr>
-          <p:cNvPr id="37" name="Text 35"/>
-          <p:cNvSpPr/>
-          <p:nvPr/>
-        </p:nvSpPr>
-        <p:spPr>
-          <a:xfrm>
-            <a:off x="5440680" y="2267712"/>
-            <a:ext cx="3108960" cy="274320"/>
-          </a:xfrm>
-          <a:prstGeom prst="rect">
-            <a:avLst/>
-          </a:prstGeom>
-          <a:noFill/>
-          <a:ln/>
-        </p:spPr>
-        <p:txBody>
-          <a:bodyPr wrap="square" lIns="0" tIns="0" rIns="0" bIns="0" rtlCol="0" anchor="ctr"/>
-          <a:lstStyle/>
-          <a:p>
-            <a:pPr marL="0" indent="0">
-              <a:buNone/>
-            </a:pPr>
-            <a:r>
-              <a:rPr lang="en-US" sz="800" dirty="0">
-                <a:solidFill>
-                  <a:srgbClr val="8888AA"/>
-                </a:solidFill>
-                <a:latin typeface="Calibri" pitchFamily="34" charset="0"/>
-                <a:ea typeface="Calibri" pitchFamily="34" charset="-122"/>
-                <a:cs typeface="Calibri" pitchFamily="34" charset="-120"/>
-              </a:rPr>
-              <a:t>Restore tags · quality score · store to TM</a:t>
-            </a:r>
-            <a:endParaRPr lang="en-US" sz="800" dirty="0"/>
-          </a:p>
-        </p:txBody>
-      </p:sp>
-      <p:sp>
-        <p:nvSpPr>
-          <p:cNvPr id="38" name="Shape 36"/>
-          <p:cNvSpPr/>
-          <p:nvPr/>
-        </p:nvSpPr>
-        <p:spPr>
-          <a:xfrm>
-            <a:off x="6839712" y="2670048"/>
-            <a:ext cx="0" cy="210312"/>
-          </a:xfrm>
-          <a:prstGeom prst="line">
-            <a:avLst/>
-          </a:prstGeom>
-          <a:noFill/>
-          <a:ln w="19050">
-            <a:solidFill>
-              <a:srgbClr val="9B59B6"/>
-            </a:solidFill>
-            <a:prstDash val="solid"/>
-          </a:ln>
-        </p:spPr>
-        <p:txBody>
-          <a:bodyPr/>
-          <a:lstStyle/>
-          <a:p>
-            <a:endParaRPr lang="en-US"/>
-          </a:p>
-        </p:txBody>
-      </p:sp>
-      <p:sp>
-        <p:nvSpPr>
-          <p:cNvPr id="39" name="Shape 37"/>
-          <p:cNvSpPr/>
-          <p:nvPr/>
-        </p:nvSpPr>
-        <p:spPr>
-          <a:xfrm>
-            <a:off x="4892040" y="2880360"/>
-            <a:ext cx="3886200" cy="749808"/>
+          <p:cNvPr id="50" name="Shape 48"/>
+          <p:cNvSpPr/>
+          <p:nvPr/>
+        </p:nvSpPr>
+        <p:spPr>
+          <a:xfrm>
+            <a:off x="4069080" y="4417607"/>
+            <a:ext cx="2286000" cy="548640"/>
           </a:xfrm>
           <a:prstGeom prst="rect">
             <a:avLst/>
@@ -11959,14 +12811,14 @@
       </p:sp>
       <p:sp>
         <p:nvSpPr>
-          <p:cNvPr id="40" name="Shape 38"/>
-          <p:cNvSpPr/>
-          <p:nvPr/>
-        </p:nvSpPr>
-        <p:spPr>
-          <a:xfrm>
-            <a:off x="4892040" y="2880360"/>
-            <a:ext cx="54864" cy="749808"/>
+          <p:cNvPr id="51" name="Shape 49"/>
+          <p:cNvSpPr/>
+          <p:nvPr/>
+        </p:nvSpPr>
+        <p:spPr>
+          <a:xfrm>
+            <a:off x="4069080" y="4417607"/>
+            <a:ext cx="54864" cy="548640"/>
           </a:xfrm>
           <a:prstGeom prst="rect">
             <a:avLst/>
@@ -11991,77 +12843,38 @@
       </p:sp>
       <p:sp>
         <p:nvSpPr>
-          <p:cNvPr id="41" name="Text 39"/>
-          <p:cNvSpPr/>
-          <p:nvPr/>
-        </p:nvSpPr>
-        <p:spPr>
-          <a:xfrm>
-            <a:off x="5029200" y="2953512"/>
-            <a:ext cx="365760" cy="228600"/>
-          </a:xfrm>
-          <a:prstGeom prst="rect">
-            <a:avLst/>
-          </a:prstGeom>
-          <a:noFill/>
-          <a:ln/>
-        </p:spPr>
-        <p:txBody>
-          <a:bodyPr wrap="square" lIns="0" tIns="0" rIns="0" bIns="0" rtlCol="0" anchor="ctr"/>
-          <a:lstStyle/>
-          <a:p>
-            <a:pPr marL="0" indent="0">
-              <a:buNone/>
-            </a:pPr>
-            <a:r>
-              <a:rPr lang="en-US" sz="900" b="1" dirty="0">
+          <p:cNvPr id="52" name="Text 50"/>
+          <p:cNvSpPr/>
+          <p:nvPr/>
+        </p:nvSpPr>
+        <p:spPr>
+          <a:xfrm>
+            <a:off x="4178808" y="4490759"/>
+            <a:ext cx="2057400" cy="219456"/>
+          </a:xfrm>
+          <a:prstGeom prst="rect">
+            <a:avLst/>
+          </a:prstGeom>
+          <a:noFill/>
+          <a:ln/>
+        </p:spPr>
+        <p:txBody>
+          <a:bodyPr wrap="square" lIns="0" tIns="0" rIns="0" bIns="0" rtlCol="0" anchor="ctr"/>
+          <a:lstStyle/>
+          <a:p>
+            <a:pPr marL="0" indent="0">
+              <a:buNone/>
+            </a:pPr>
+            <a:r>
+              <a:rPr lang="en-US" sz="1100" b="1" dirty="0">
                 <a:solidFill>
                   <a:srgbClr val="FFB800"/>
-                </a:solidFill>
-                <a:latin typeface="Consolas" pitchFamily="34" charset="0"/>
-                <a:ea typeface="Consolas" pitchFamily="34" charset="-122"/>
-                <a:cs typeface="Consolas" pitchFamily="34" charset="-120"/>
-              </a:rPr>
-              <a:t>07</a:t>
-            </a:r>
-            <a:endParaRPr lang="en-US" sz="900" dirty="0"/>
-          </a:p>
-        </p:txBody>
-      </p:sp>
-      <p:sp>
-        <p:nvSpPr>
-          <p:cNvPr id="42" name="Text 40"/>
-          <p:cNvSpPr/>
-          <p:nvPr/>
-        </p:nvSpPr>
-        <p:spPr>
-          <a:xfrm>
-            <a:off x="5440680" y="2953512"/>
-            <a:ext cx="3108960" cy="256032"/>
-          </a:xfrm>
-          <a:prstGeom prst="rect">
-            <a:avLst/>
-          </a:prstGeom>
-          <a:noFill/>
-          <a:ln/>
-        </p:spPr>
-        <p:txBody>
-          <a:bodyPr wrap="square" lIns="0" tIns="0" rIns="0" bIns="0" rtlCol="0" anchor="ctr"/>
-          <a:lstStyle/>
-          <a:p>
-            <a:pPr marL="0" indent="0">
-              <a:buNone/>
-            </a:pPr>
-            <a:r>
-              <a:rPr lang="en-US" sz="1100" b="1" dirty="0">
-                <a:solidFill>
-                  <a:srgbClr val="E8E8F0"/>
                 </a:solidFill>
                 <a:latin typeface="Calibri" pitchFamily="34" charset="0"/>
                 <a:ea typeface="Calibri" pitchFamily="34" charset="-122"/>
                 <a:cs typeface="Calibri" pitchFamily="34" charset="-120"/>
               </a:rPr>
-              <a:t>Confidence Gate</a:t>
+              <a:t>Human Review</a:t>
             </a:r>
             <a:endParaRPr lang="en-US" sz="1100" dirty="0"/>
           </a:p>
@@ -12069,30 +12882,30 @@
       </p:sp>
       <p:sp>
         <p:nvSpPr>
-          <p:cNvPr id="43" name="Text 41"/>
-          <p:cNvSpPr/>
-          <p:nvPr/>
-        </p:nvSpPr>
-        <p:spPr>
-          <a:xfrm>
-            <a:off x="5440680" y="3227832"/>
-            <a:ext cx="3108960" cy="274320"/>
-          </a:xfrm>
-          <a:prstGeom prst="rect">
-            <a:avLst/>
-          </a:prstGeom>
-          <a:noFill/>
-          <a:ln/>
-        </p:spPr>
-        <p:txBody>
-          <a:bodyPr wrap="square" lIns="0" tIns="0" rIns="0" bIns="0" rtlCol="0" anchor="ctr"/>
-          <a:lstStyle/>
-          <a:p>
-            <a:pPr marL="0" indent="0">
-              <a:buNone/>
-            </a:pPr>
-            <a:r>
-              <a:rPr lang="en-US" sz="800" dirty="0">
+          <p:cNvPr id="53" name="Text 51"/>
+          <p:cNvSpPr/>
+          <p:nvPr/>
+        </p:nvSpPr>
+        <p:spPr>
+          <a:xfrm>
+            <a:off x="4178808" y="4710215"/>
+            <a:ext cx="2057400" cy="182880"/>
+          </a:xfrm>
+          <a:prstGeom prst="rect">
+            <a:avLst/>
+          </a:prstGeom>
+          <a:noFill/>
+          <a:ln/>
+        </p:spPr>
+        <p:txBody>
+          <a:bodyPr wrap="square" lIns="0" tIns="0" rIns="0" bIns="0" rtlCol="0" anchor="ctr"/>
+          <a:lstStyle/>
+          <a:p>
+            <a:pPr marL="0" indent="0">
+              <a:buNone/>
+            </a:pPr>
+            <a:r>
+              <a:rPr lang="en-US" sz="900" dirty="0">
                 <a:solidFill>
                   <a:srgbClr val="8888AA"/>
                 </a:solidFill>
@@ -12100,225 +12913,7 @@
                 <a:ea typeface="Calibri" pitchFamily="34" charset="-122"/>
                 <a:cs typeface="Calibri" pitchFamily="34" charset="-120"/>
               </a:rPr>
-              <a:t>&gt;95% auto-publish · 80-95% review · &lt;80% block</a:t>
-            </a:r>
-            <a:endParaRPr lang="en-US" sz="800" dirty="0"/>
-          </a:p>
-        </p:txBody>
-      </p:sp>
-      <p:sp>
-        <p:nvSpPr>
-          <p:cNvPr id="44" name="Shape 42"/>
-          <p:cNvSpPr/>
-          <p:nvPr/>
-        </p:nvSpPr>
-        <p:spPr>
-          <a:xfrm>
-            <a:off x="4114800" y="2350008"/>
-            <a:ext cx="777240" cy="0"/>
-          </a:xfrm>
-          <a:prstGeom prst="line">
-            <a:avLst/>
-          </a:prstGeom>
-          <a:noFill/>
-          <a:ln w="19050">
-            <a:solidFill>
-              <a:srgbClr val="00D4A0"/>
-            </a:solidFill>
-            <a:prstDash val="solid"/>
-          </a:ln>
-        </p:spPr>
-        <p:txBody>
-          <a:bodyPr/>
-          <a:lstStyle/>
-          <a:p>
-            <a:endParaRPr lang="en-US"/>
-          </a:p>
-        </p:txBody>
-      </p:sp>
-      <p:sp>
-        <p:nvSpPr>
-          <p:cNvPr id="45" name="Text 43"/>
-          <p:cNvSpPr/>
-          <p:nvPr/>
-        </p:nvSpPr>
-        <p:spPr>
-          <a:xfrm>
-            <a:off x="4096512" y="2176272"/>
-            <a:ext cx="822960" cy="164592"/>
-          </a:xfrm>
-          <a:prstGeom prst="rect">
-            <a:avLst/>
-          </a:prstGeom>
-          <a:noFill/>
-          <a:ln/>
-        </p:spPr>
-        <p:txBody>
-          <a:bodyPr wrap="square" rtlCol="0" anchor="ctr"/>
-          <a:lstStyle/>
-          <a:p>
-            <a:pPr marL="0" indent="0" algn="ctr">
-              <a:buNone/>
-            </a:pPr>
-            <a:r>
-              <a:rPr lang="en-US" sz="700" dirty="0">
-                <a:solidFill>
-                  <a:srgbClr val="00D4A0"/>
-                </a:solidFill>
-                <a:latin typeface="Consolas" pitchFamily="34" charset="0"/>
-                <a:ea typeface="Consolas" pitchFamily="34" charset="-122"/>
-                <a:cs typeface="Consolas" pitchFamily="34" charset="-120"/>
-              </a:rPr>
-              <a:t>routes to →</a:t>
-            </a:r>
-            <a:endParaRPr lang="en-US" sz="700" dirty="0"/>
-          </a:p>
-        </p:txBody>
-      </p:sp>
-      <p:sp>
-        <p:nvSpPr>
-          <p:cNvPr id="46" name="Shape 44"/>
-          <p:cNvSpPr/>
-          <p:nvPr/>
-        </p:nvSpPr>
-        <p:spPr>
-          <a:xfrm>
-            <a:off x="914400" y="4480560"/>
-            <a:ext cx="2286000" cy="548640"/>
-          </a:xfrm>
-          <a:prstGeom prst="rect">
-            <a:avLst/>
-          </a:prstGeom>
-          <a:solidFill>
-            <a:srgbClr val="0E0E20"/>
-          </a:solidFill>
-          <a:ln w="12700">
-            <a:solidFill>
-              <a:srgbClr val="00D4A0"/>
-            </a:solidFill>
-            <a:prstDash val="solid"/>
-          </a:ln>
-          <a:effectLst>
-            <a:outerShdw blurRad="101600" dist="25400" dir="8100000" algn="bl" rotWithShape="0">
-              <a:srgbClr val="000000">
-                <a:alpha val="25000"/>
-              </a:srgbClr>
-            </a:outerShdw>
-          </a:effectLst>
-        </p:spPr>
-        <p:txBody>
-          <a:bodyPr/>
-          <a:lstStyle/>
-          <a:p>
-            <a:endParaRPr lang="en-US"/>
-          </a:p>
-        </p:txBody>
-      </p:sp>
-      <p:sp>
-        <p:nvSpPr>
-          <p:cNvPr id="47" name="Shape 45"/>
-          <p:cNvSpPr/>
-          <p:nvPr/>
-        </p:nvSpPr>
-        <p:spPr>
-          <a:xfrm>
-            <a:off x="914400" y="4480560"/>
-            <a:ext cx="54864" cy="548640"/>
-          </a:xfrm>
-          <a:prstGeom prst="rect">
-            <a:avLst/>
-          </a:prstGeom>
-          <a:solidFill>
-            <a:srgbClr val="00D4A0"/>
-          </a:solidFill>
-          <a:ln w="12700">
-            <a:solidFill>
-              <a:srgbClr val="00D4A0"/>
-            </a:solidFill>
-            <a:prstDash val="solid"/>
-          </a:ln>
-        </p:spPr>
-        <p:txBody>
-          <a:bodyPr/>
-          <a:lstStyle/>
-          <a:p>
-            <a:endParaRPr lang="en-US"/>
-          </a:p>
-        </p:txBody>
-      </p:sp>
-      <p:sp>
-        <p:nvSpPr>
-          <p:cNvPr id="48" name="Text 46"/>
-          <p:cNvSpPr/>
-          <p:nvPr/>
-        </p:nvSpPr>
-        <p:spPr>
-          <a:xfrm>
-            <a:off x="1024128" y="4553712"/>
-            <a:ext cx="2057400" cy="219456"/>
-          </a:xfrm>
-          <a:prstGeom prst="rect">
-            <a:avLst/>
-          </a:prstGeom>
-          <a:noFill/>
-          <a:ln/>
-        </p:spPr>
-        <p:txBody>
-          <a:bodyPr wrap="square" lIns="0" tIns="0" rIns="0" bIns="0" rtlCol="0" anchor="ctr"/>
-          <a:lstStyle/>
-          <a:p>
-            <a:pPr marL="0" indent="0">
-              <a:buNone/>
-            </a:pPr>
-            <a:r>
-              <a:rPr lang="en-US" sz="1100" b="1" dirty="0">
-                <a:solidFill>
-                  <a:srgbClr val="00D4A0"/>
-                </a:solidFill>
-                <a:latin typeface="Calibri" pitchFamily="34" charset="0"/>
-                <a:ea typeface="Calibri" pitchFamily="34" charset="-122"/>
-                <a:cs typeface="Calibri" pitchFamily="34" charset="-120"/>
-              </a:rPr>
-              <a:t>Auto Publish</a:t>
-            </a:r>
-            <a:endParaRPr lang="en-US" sz="1100" dirty="0"/>
-          </a:p>
-        </p:txBody>
-      </p:sp>
-      <p:sp>
-        <p:nvSpPr>
-          <p:cNvPr id="49" name="Text 47"/>
-          <p:cNvSpPr/>
-          <p:nvPr/>
-        </p:nvSpPr>
-        <p:spPr>
-          <a:xfrm>
-            <a:off x="1024128" y="4773168"/>
-            <a:ext cx="2057400" cy="182880"/>
-          </a:xfrm>
-          <a:prstGeom prst="rect">
-            <a:avLst/>
-          </a:prstGeom>
-          <a:noFill/>
-          <a:ln/>
-        </p:spPr>
-        <p:txBody>
-          <a:bodyPr wrap="square" lIns="0" tIns="0" rIns="0" bIns="0" rtlCol="0" anchor="ctr"/>
-          <a:lstStyle/>
-          <a:p>
-            <a:pPr marL="0" indent="0">
-              <a:buNone/>
-            </a:pPr>
-            <a:r>
-              <a:rPr lang="en-US" sz="900" dirty="0">
-                <a:solidFill>
-                  <a:srgbClr val="8888AA"/>
-                </a:solidFill>
-                <a:latin typeface="Calibri" pitchFamily="34" charset="0"/>
-                <a:ea typeface="Calibri" pitchFamily="34" charset="-122"/>
-                <a:cs typeface="Calibri" pitchFamily="34" charset="-120"/>
-              </a:rPr>
-              <a:t>Storefront CDN</a:t>
+              <a:t>Editor queue</a:t>
             </a:r>
             <a:endParaRPr lang="en-US" sz="900" dirty="0"/>
           </a:p>
@@ -12326,162 +12921,13 @@
       </p:sp>
       <p:sp>
         <p:nvSpPr>
-          <p:cNvPr id="50" name="Shape 48"/>
-          <p:cNvSpPr/>
-          <p:nvPr/>
-        </p:nvSpPr>
-        <p:spPr>
-          <a:xfrm>
-            <a:off x="3520440" y="4480560"/>
-            <a:ext cx="2286000" cy="548640"/>
-          </a:xfrm>
-          <a:prstGeom prst="rect">
-            <a:avLst/>
-          </a:prstGeom>
-          <a:solidFill>
-            <a:srgbClr val="0E0E20"/>
-          </a:solidFill>
-          <a:ln w="12700">
-            <a:solidFill>
-              <a:srgbClr val="FFB800"/>
-            </a:solidFill>
-            <a:prstDash val="solid"/>
-          </a:ln>
-          <a:effectLst>
-            <a:outerShdw blurRad="101600" dist="25400" dir="8100000" algn="bl" rotWithShape="0">
-              <a:srgbClr val="000000">
-                <a:alpha val="25000"/>
-              </a:srgbClr>
-            </a:outerShdw>
-          </a:effectLst>
-        </p:spPr>
-        <p:txBody>
-          <a:bodyPr/>
-          <a:lstStyle/>
-          <a:p>
-            <a:endParaRPr lang="en-US"/>
-          </a:p>
-        </p:txBody>
-      </p:sp>
-      <p:sp>
-        <p:nvSpPr>
-          <p:cNvPr id="51" name="Shape 49"/>
-          <p:cNvSpPr/>
-          <p:nvPr/>
-        </p:nvSpPr>
-        <p:spPr>
-          <a:xfrm>
-            <a:off x="3520440" y="4480560"/>
-            <a:ext cx="54864" cy="548640"/>
-          </a:xfrm>
-          <a:prstGeom prst="rect">
-            <a:avLst/>
-          </a:prstGeom>
-          <a:solidFill>
-            <a:srgbClr val="FFB800"/>
-          </a:solidFill>
-          <a:ln w="12700">
-            <a:solidFill>
-              <a:srgbClr val="FFB800"/>
-            </a:solidFill>
-            <a:prstDash val="solid"/>
-          </a:ln>
-        </p:spPr>
-        <p:txBody>
-          <a:bodyPr/>
-          <a:lstStyle/>
-          <a:p>
-            <a:endParaRPr lang="en-US"/>
-          </a:p>
-        </p:txBody>
-      </p:sp>
-      <p:sp>
-        <p:nvSpPr>
-          <p:cNvPr id="52" name="Text 50"/>
-          <p:cNvSpPr/>
-          <p:nvPr/>
-        </p:nvSpPr>
-        <p:spPr>
-          <a:xfrm>
-            <a:off x="3630168" y="4553712"/>
-            <a:ext cx="2057400" cy="219456"/>
-          </a:xfrm>
-          <a:prstGeom prst="rect">
-            <a:avLst/>
-          </a:prstGeom>
-          <a:noFill/>
-          <a:ln/>
-        </p:spPr>
-        <p:txBody>
-          <a:bodyPr wrap="square" lIns="0" tIns="0" rIns="0" bIns="0" rtlCol="0" anchor="ctr"/>
-          <a:lstStyle/>
-          <a:p>
-            <a:pPr marL="0" indent="0">
-              <a:buNone/>
-            </a:pPr>
-            <a:r>
-              <a:rPr lang="en-US" sz="1100" b="1" dirty="0">
-                <a:solidFill>
-                  <a:srgbClr val="FFB800"/>
-                </a:solidFill>
-                <a:latin typeface="Calibri" pitchFamily="34" charset="0"/>
-                <a:ea typeface="Calibri" pitchFamily="34" charset="-122"/>
-                <a:cs typeface="Calibri" pitchFamily="34" charset="-120"/>
-              </a:rPr>
-              <a:t>Human Review</a:t>
-            </a:r>
-            <a:endParaRPr lang="en-US" sz="1100" dirty="0"/>
-          </a:p>
-        </p:txBody>
-      </p:sp>
-      <p:sp>
-        <p:nvSpPr>
-          <p:cNvPr id="53" name="Text 51"/>
-          <p:cNvSpPr/>
-          <p:nvPr/>
-        </p:nvSpPr>
-        <p:spPr>
-          <a:xfrm>
-            <a:off x="3630168" y="4773168"/>
-            <a:ext cx="2057400" cy="182880"/>
-          </a:xfrm>
-          <a:prstGeom prst="rect">
-            <a:avLst/>
-          </a:prstGeom>
-          <a:noFill/>
-          <a:ln/>
-        </p:spPr>
-        <p:txBody>
-          <a:bodyPr wrap="square" lIns="0" tIns="0" rIns="0" bIns="0" rtlCol="0" anchor="ctr"/>
-          <a:lstStyle/>
-          <a:p>
-            <a:pPr marL="0" indent="0">
-              <a:buNone/>
-            </a:pPr>
-            <a:r>
-              <a:rPr lang="en-US" sz="900" dirty="0">
-                <a:solidFill>
-                  <a:srgbClr val="8888AA"/>
-                </a:solidFill>
-                <a:latin typeface="Calibri" pitchFamily="34" charset="0"/>
-                <a:ea typeface="Calibri" pitchFamily="34" charset="-122"/>
-                <a:cs typeface="Calibri" pitchFamily="34" charset="-120"/>
-              </a:rPr>
-              <a:t>Editor queue</a:t>
-            </a:r>
-            <a:endParaRPr lang="en-US" sz="900" dirty="0"/>
-          </a:p>
-        </p:txBody>
-      </p:sp>
-      <p:sp>
-        <p:nvSpPr>
           <p:cNvPr id="54" name="Shape 52"/>
           <p:cNvSpPr/>
           <p:nvPr/>
         </p:nvSpPr>
         <p:spPr>
           <a:xfrm>
-            <a:off x="6126480" y="4480560"/>
+            <a:off x="6675120" y="4417607"/>
             <a:ext cx="2286000" cy="548640"/>
           </a:xfrm>
           <a:prstGeom prst="rect">
@@ -12520,7 +12966,7 @@
         </p:nvSpPr>
         <p:spPr>
           <a:xfrm>
-            <a:off x="6126480" y="4480560"/>
+            <a:off x="6675120" y="4417607"/>
             <a:ext cx="54864" cy="548640"/>
           </a:xfrm>
           <a:prstGeom prst="rect">
@@ -12552,7 +12998,7 @@
         </p:nvSpPr>
         <p:spPr>
           <a:xfrm>
-            <a:off x="6236208" y="4553712"/>
+            <a:off x="6784848" y="4490759"/>
             <a:ext cx="2057400" cy="219456"/>
           </a:xfrm>
           <a:prstGeom prst="rect">
@@ -12591,7 +13037,7 @@
         </p:nvSpPr>
         <p:spPr>
           <a:xfrm>
-            <a:off x="6236208" y="4773168"/>
+            <a:off x="6784848" y="4710215"/>
             <a:ext cx="2057400" cy="182880"/>
           </a:xfrm>
           <a:prstGeom prst="rect">
@@ -16286,7 +16732,7 @@
         <p:spPr>
           <a:xfrm>
             <a:off x="365760" y="1188720"/>
-            <a:ext cx="2697480" cy="2743200"/>
+            <a:ext cx="2788920" cy="2743200"/>
           </a:xfrm>
           <a:prstGeom prst="rect">
             <a:avLst/>
@@ -17077,77 +17523,6 @@
       </p:sp>
       <p:sp>
         <p:nvSpPr>
-          <p:cNvPr id="27" name="Shape 25"/>
-          <p:cNvSpPr/>
-          <p:nvPr/>
-        </p:nvSpPr>
-        <p:spPr>
-          <a:xfrm>
-            <a:off x="502920" y="3639312"/>
-            <a:ext cx="2468880" cy="182880"/>
-          </a:xfrm>
-          <a:prstGeom prst="rect">
-            <a:avLst/>
-          </a:prstGeom>
-          <a:solidFill>
-            <a:srgbClr val="12122A"/>
-          </a:solidFill>
-          <a:ln w="12700">
-            <a:solidFill>
-              <a:srgbClr val="1E2040"/>
-            </a:solidFill>
-            <a:prstDash val="solid"/>
-          </a:ln>
-        </p:spPr>
-        <p:txBody>
-          <a:bodyPr/>
-          <a:lstStyle/>
-          <a:p>
-            <a:endParaRPr lang="en-US"/>
-          </a:p>
-        </p:txBody>
-      </p:sp>
-      <p:sp>
-        <p:nvSpPr>
-          <p:cNvPr id="28" name="Text 26"/>
-          <p:cNvSpPr/>
-          <p:nvPr/>
-        </p:nvSpPr>
-        <p:spPr>
-          <a:xfrm>
-            <a:off x="530352" y="3648456"/>
-            <a:ext cx="2414016" cy="164592"/>
-          </a:xfrm>
-          <a:prstGeom prst="rect">
-            <a:avLst/>
-          </a:prstGeom>
-          <a:noFill/>
-          <a:ln/>
-        </p:spPr>
-        <p:txBody>
-          <a:bodyPr wrap="square" lIns="0" tIns="0" rIns="0" bIns="0" rtlCol="0" anchor="ctr"/>
-          <a:lstStyle/>
-          <a:p>
-            <a:pPr marL="0" indent="0">
-              <a:buNone/>
-            </a:pPr>
-            <a:r>
-              <a:rPr lang="en-US" sz="750" dirty="0">
-                <a:solidFill>
-                  <a:srgbClr val="00D4A0"/>
-                </a:solidFill>
-                <a:latin typeface="Consolas" pitchFamily="34" charset="0"/>
-                <a:ea typeface="Consolas" pitchFamily="34" charset="-122"/>
-                <a:cs typeface="Consolas" pitchFamily="34" charset="-120"/>
-              </a:rPr>
-              <a:t>pip install unbabel-comet</a:t>
-            </a:r>
-            <a:endParaRPr lang="en-US" sz="750" dirty="0"/>
-          </a:p>
-        </p:txBody>
-      </p:sp>
-      <p:sp>
-        <p:nvSpPr>
           <p:cNvPr id="29" name="Shape 27"/>
           <p:cNvSpPr/>
           <p:nvPr/>
@@ -17155,7 +17530,7 @@
         <p:spPr>
           <a:xfrm>
             <a:off x="3246120" y="1188720"/>
-            <a:ext cx="2697480" cy="2743200"/>
+            <a:ext cx="2788920" cy="2743200"/>
           </a:xfrm>
           <a:prstGeom prst="rect">
             <a:avLst/>
@@ -17946,77 +18321,6 @@
       </p:sp>
       <p:sp>
         <p:nvSpPr>
-          <p:cNvPr id="51" name="Shape 49"/>
-          <p:cNvSpPr/>
-          <p:nvPr/>
-        </p:nvSpPr>
-        <p:spPr>
-          <a:xfrm>
-            <a:off x="3383280" y="3639312"/>
-            <a:ext cx="2468880" cy="182880"/>
-          </a:xfrm>
-          <a:prstGeom prst="rect">
-            <a:avLst/>
-          </a:prstGeom>
-          <a:solidFill>
-            <a:srgbClr val="12122A"/>
-          </a:solidFill>
-          <a:ln w="12700">
-            <a:solidFill>
-              <a:srgbClr val="1E2040"/>
-            </a:solidFill>
-            <a:prstDash val="solid"/>
-          </a:ln>
-        </p:spPr>
-        <p:txBody>
-          <a:bodyPr/>
-          <a:lstStyle/>
-          <a:p>
-            <a:endParaRPr lang="en-US"/>
-          </a:p>
-        </p:txBody>
-      </p:sp>
-      <p:sp>
-        <p:nvSpPr>
-          <p:cNvPr id="52" name="Text 50"/>
-          <p:cNvSpPr/>
-          <p:nvPr/>
-        </p:nvSpPr>
-        <p:spPr>
-          <a:xfrm>
-            <a:off x="3410712" y="3648456"/>
-            <a:ext cx="2414016" cy="164592"/>
-          </a:xfrm>
-          <a:prstGeom prst="rect">
-            <a:avLst/>
-          </a:prstGeom>
-          <a:noFill/>
-          <a:ln/>
-        </p:spPr>
-        <p:txBody>
-          <a:bodyPr wrap="square" lIns="0" tIns="0" rIns="0" bIns="0" rtlCol="0" anchor="ctr"/>
-          <a:lstStyle/>
-          <a:p>
-            <a:pPr marL="0" indent="0">
-              <a:buNone/>
-            </a:pPr>
-            <a:r>
-              <a:rPr lang="en-US" sz="750" dirty="0">
-                <a:solidFill>
-                  <a:srgbClr val="4285F4"/>
-                </a:solidFill>
-                <a:latin typeface="Consolas" pitchFamily="34" charset="0"/>
-                <a:ea typeface="Consolas" pitchFamily="34" charset="-122"/>
-                <a:cs typeface="Consolas" pitchFamily="34" charset="-120"/>
-              </a:rPr>
-              <a:t>clone google-research/bleurt</a:t>
-            </a:r>
-            <a:endParaRPr lang="en-US" sz="750" dirty="0"/>
-          </a:p>
-        </p:txBody>
-      </p:sp>
-      <p:sp>
-        <p:nvSpPr>
           <p:cNvPr id="53" name="Shape 51"/>
           <p:cNvSpPr/>
           <p:nvPr/>
@@ -18024,7 +18328,7 @@
         <p:spPr>
           <a:xfrm>
             <a:off x="6126480" y="1188720"/>
-            <a:ext cx="2697480" cy="2743200"/>
+            <a:ext cx="2788920" cy="2743200"/>
           </a:xfrm>
           <a:prstGeom prst="rect">
             <a:avLst/>
@@ -18815,77 +19119,6 @@
       </p:sp>
       <p:sp>
         <p:nvSpPr>
-          <p:cNvPr id="75" name="Shape 73"/>
-          <p:cNvSpPr/>
-          <p:nvPr/>
-        </p:nvSpPr>
-        <p:spPr>
-          <a:xfrm>
-            <a:off x="6263640" y="3639312"/>
-            <a:ext cx="2468880" cy="182880"/>
-          </a:xfrm>
-          <a:prstGeom prst="rect">
-            <a:avLst/>
-          </a:prstGeom>
-          <a:solidFill>
-            <a:srgbClr val="12122A"/>
-          </a:solidFill>
-          <a:ln w="12700">
-            <a:solidFill>
-              <a:srgbClr val="1E2040"/>
-            </a:solidFill>
-            <a:prstDash val="solid"/>
-          </a:ln>
-        </p:spPr>
-        <p:txBody>
-          <a:bodyPr/>
-          <a:lstStyle/>
-          <a:p>
-            <a:endParaRPr lang="en-US"/>
-          </a:p>
-        </p:txBody>
-      </p:sp>
-      <p:sp>
-        <p:nvSpPr>
-          <p:cNvPr id="76" name="Text 74"/>
-          <p:cNvSpPr/>
-          <p:nvPr/>
-        </p:nvSpPr>
-        <p:spPr>
-          <a:xfrm>
-            <a:off x="6291072" y="3648456"/>
-            <a:ext cx="2414016" cy="164592"/>
-          </a:xfrm>
-          <a:prstGeom prst="rect">
-            <a:avLst/>
-          </a:prstGeom>
-          <a:noFill/>
-          <a:ln/>
-        </p:spPr>
-        <p:txBody>
-          <a:bodyPr wrap="square" lIns="0" tIns="0" rIns="0" bIns="0" rtlCol="0" anchor="ctr"/>
-          <a:lstStyle/>
-          <a:p>
-            <a:pPr marL="0" indent="0">
-              <a:buNone/>
-            </a:pPr>
-            <a:r>
-              <a:rPr lang="en-US" sz="750" dirty="0">
-                <a:solidFill>
-                  <a:srgbClr val="FFB800"/>
-                </a:solidFill>
-                <a:latin typeface="Consolas" pitchFamily="34" charset="0"/>
-                <a:ea typeface="Consolas" pitchFamily="34" charset="-122"/>
-                <a:cs typeface="Consolas" pitchFamily="34" charset="-120"/>
-              </a:rPr>
-              <a:t>pip install sacrebleu</a:t>
-            </a:r>
-            <a:endParaRPr lang="en-US" sz="750" dirty="0"/>
-          </a:p>
-        </p:txBody>
-      </p:sp>
-      <p:sp>
-        <p:nvSpPr>
           <p:cNvPr id="77" name="Shape 75"/>
           <p:cNvSpPr/>
           <p:nvPr/>
@@ -18893,7 +19126,7 @@
         <p:spPr>
           <a:xfrm>
             <a:off x="365760" y="4041648"/>
-            <a:ext cx="8412480" cy="914400"/>
+            <a:ext cx="8549640" cy="914400"/>
           </a:xfrm>
           <a:prstGeom prst="rect">
             <a:avLst/>
@@ -19284,7 +19517,7 @@
                 <a:ea typeface="Consolas" pitchFamily="34" charset="-122"/>
                 <a:cs typeface="Consolas" pitchFamily="34" charset="-120"/>
               </a:rPr>
-              <a:t>Phase 1  —  Day 1</a:t>
+              <a:t>Phase 1</a:t>
             </a:r>
             <a:endParaRPr lang="en-US" sz="800" dirty="0"/>
           </a:p>
@@ -19760,7 +19993,7 @@
                 <a:ea typeface="Consolas" pitchFamily="34" charset="-122"/>
                 <a:cs typeface="Consolas" pitchFamily="34" charset="-120"/>
               </a:rPr>
-              <a:t>Phase 2  —  Week 1</a:t>
+              <a:t>Phase 2</a:t>
             </a:r>
             <a:endParaRPr lang="en-US" sz="800" dirty="0"/>
           </a:p>
@@ -20236,7 +20469,7 @@
                 <a:ea typeface="Consolas" pitchFamily="34" charset="-122"/>
                 <a:cs typeface="Consolas" pitchFamily="34" charset="-120"/>
               </a:rPr>
-              <a:t>Phase 3  —  Month 1</a:t>
+              <a:t>Phase 3</a:t>
             </a:r>
             <a:endParaRPr lang="en-US" sz="800" dirty="0"/>
           </a:p>

</xml_diff>